<commit_message>
Dodaj fotografije u prezentaciju o Bati Zivojinovicu
Ugradjene slobodno licencirane slike sa Wikimedia Commons (portreti,
fotografija iz Skupstine, Kosmaj, Arena u Puli, postanska marka) sa
zlatnim okvirom i potpisima. Dodata atribucija izvora na poslednjem
slajdu. Skripta i preuzete slike (folder slike/) ukljuceni.

Co-Authored-By: Claude Opus 4.8 <noreply@anthropic.com>
Claude-Session: https://claude.ai/code/session_01VHCyUBMH6UXx5KGwtqa7SS
</commit_message>
<xml_diff>
--- a/Bata_Zivojinovic_prezentacija.pptx
+++ b/Bata_Zivojinovic_prezentacija.pptx
@@ -3196,16 +3196,81 @@
           </a:p>
         </p:txBody>
       </p:sp>
-      <p:sp>
-        <p:nvSpPr>
-          <p:cNvPr id="4" name="Rectangle 3"/>
+      <p:pic>
+        <p:nvPicPr>
+          <p:cNvPr id="4" name="Picture 3" descr="bata1.jpg"/>
+          <p:cNvPicPr>
+            <a:picLocks noChangeAspect="1"/>
+          </p:cNvPicPr>
+          <p:nvPr/>
+        </p:nvPicPr>
+        <p:blipFill>
+          <a:blip r:embed="rId2"/>
+          <a:srcRect l="10186" r="10186"/>
+          <a:stretch>
+            <a:fillRect/>
+          </a:stretch>
+        </p:blipFill>
+        <p:spPr>
+          <a:xfrm>
+            <a:off x="7955279" y="1051560"/>
+            <a:ext cx="3566160" cy="4754880"/>
+          </a:xfrm>
+          <a:prstGeom prst="rect">
+            <a:avLst/>
+          </a:prstGeom>
+          <a:ln w="38100">
+            <a:solidFill>
+              <a:srgbClr val="C9A227"/>
+            </a:solidFill>
+          </a:ln>
+        </p:spPr>
+      </p:pic>
+      <p:sp>
+        <p:nvSpPr>
+          <p:cNvPr id="5" name="TextBox 4"/>
+          <p:cNvSpPr txBox="1"/>
+          <p:nvPr/>
+        </p:nvSpPr>
+        <p:spPr>
+          <a:xfrm>
+            <a:off x="640080" y="868680"/>
+            <a:ext cx="7040880" cy="548640"/>
+          </a:xfrm>
+          <a:prstGeom prst="rect">
+            <a:avLst/>
+          </a:prstGeom>
+          <a:noFill/>
+        </p:spPr>
+        <p:txBody>
+          <a:bodyPr wrap="square" anchor="t">
+            <a:spAutoFit/>
+          </a:bodyPr>
+          <a:lstStyle/>
+          <a:p>
+            <a:pPr algn="l"/>
+            <a:r>
+              <a:rPr sz="1500" b="1" i="0">
+                <a:solidFill>
+                  <a:srgbClr val="C9A227"/>
+                </a:solidFill>
+                <a:latin typeface="Calibri"/>
+              </a:rPr>
+              <a:t>MATURSKA / SEMINARSKA PREZENTACIJA</a:t>
+            </a:r>
+          </a:p>
+        </p:txBody>
+      </p:sp>
+      <p:sp>
+        <p:nvSpPr>
+          <p:cNvPr id="6" name="Rectangle 5"/>
           <p:cNvSpPr/>
           <p:nvPr/>
         </p:nvSpPr>
         <p:spPr>
           <a:xfrm>
-            <a:off x="0" y="2331720"/>
-            <a:ext cx="12191695" cy="50000"/>
+            <a:off x="640080" y="2011680"/>
+            <a:ext cx="6858000" cy="50000"/>
           </a:xfrm>
           <a:prstGeom prst="rect">
             <a:avLst/>
@@ -3242,58 +3307,50 @@
       </p:sp>
       <p:sp>
         <p:nvSpPr>
-          <p:cNvPr id="5" name="Rectangle 4"/>
-          <p:cNvSpPr/>
-          <p:nvPr/>
-        </p:nvSpPr>
-        <p:spPr>
-          <a:xfrm>
-            <a:off x="0" y="4160520"/>
-            <a:ext cx="12191695" cy="50000"/>
-          </a:xfrm>
-          <a:prstGeom prst="rect">
-            <a:avLst/>
-          </a:prstGeom>
-          <a:solidFill>
-            <a:srgbClr val="C9A227"/>
-          </a:solidFill>
-          <a:ln>
-            <a:noFill/>
-          </a:ln>
-          <a:effectLst/>
-        </p:spPr>
-        <p:style>
-          <a:lnRef idx="1">
-            <a:schemeClr val="accent1"/>
-          </a:lnRef>
-          <a:fillRef idx="3">
-            <a:schemeClr val="accent1"/>
-          </a:fillRef>
-          <a:effectRef idx="2">
-            <a:schemeClr val="accent1"/>
-          </a:effectRef>
-          <a:fontRef idx="minor">
-            <a:schemeClr val="lt1"/>
-          </a:fontRef>
-        </p:style>
-        <p:txBody>
-          <a:bodyPr rtlCol="0" anchor="ctr"/>
-          <a:lstStyle/>
-          <a:p>
-            <a:pPr algn="ctr"/>
-          </a:p>
-        </p:txBody>
-      </p:sp>
-      <p:sp>
-        <p:nvSpPr>
-          <p:cNvPr id="6" name="TextBox 5"/>
+          <p:cNvPr id="7" name="TextBox 6"/>
           <p:cNvSpPr txBox="1"/>
           <p:nvPr/>
         </p:nvSpPr>
         <p:spPr>
           <a:xfrm>
-            <a:off x="914400" y="868680"/>
-            <a:ext cx="10332720" cy="548640"/>
+            <a:off x="640080" y="2240280"/>
+            <a:ext cx="7040880" cy="1828800"/>
+          </a:xfrm>
+          <a:prstGeom prst="rect">
+            <a:avLst/>
+          </a:prstGeom>
+          <a:noFill/>
+        </p:spPr>
+        <p:txBody>
+          <a:bodyPr wrap="square" anchor="ctr">
+            <a:spAutoFit/>
+          </a:bodyPr>
+          <a:lstStyle/>
+          <a:p>
+            <a:pPr algn="l"/>
+            <a:r>
+              <a:rPr sz="4000" b="1" i="0">
+                <a:solidFill>
+                  <a:srgbClr val="FFFFFF"/>
+                </a:solidFill>
+                <a:latin typeface="Calibri"/>
+              </a:rPr>
+              <a:t>VELIMIR
+„BATA“ ŽIVOJINOVIĆ</a:t>
+            </a:r>
+          </a:p>
+        </p:txBody>
+      </p:sp>
+      <p:sp>
+        <p:nvSpPr>
+          <p:cNvPr id="8" name="TextBox 7"/>
+          <p:cNvSpPr txBox="1"/>
+          <p:nvPr/>
+        </p:nvSpPr>
+        <p:spPr>
+          <a:xfrm>
+            <a:off x="640080" y="4297680"/>
+            <a:ext cx="7040880" cy="1188720"/>
           </a:xfrm>
           <a:prstGeom prst="rect">
             <a:avLst/>
@@ -3306,64 +3363,29 @@
           </a:bodyPr>
           <a:lstStyle/>
           <a:p>
-            <a:pPr algn="ctr"/>
-            <a:r>
-              <a:rPr sz="1600" b="1" i="0">
-                <a:solidFill>
-                  <a:srgbClr val="C9A227"/>
-                </a:solidFill>
-                <a:latin typeface="Calibri"/>
-              </a:rPr>
-              <a:t>MATURSKA / SEMINARSKA PREZENTACIJA</a:t>
-            </a:r>
-          </a:p>
-        </p:txBody>
-      </p:sp>
-      <p:sp>
-        <p:nvSpPr>
-          <p:cNvPr id="7" name="TextBox 6"/>
+            <a:pPr algn="l"/>
+            <a:r>
+              <a:rPr sz="1900" b="0" i="1">
+                <a:solidFill>
+                  <a:srgbClr val="F4F1EA"/>
+                </a:solidFill>
+                <a:latin typeface="Calibri"/>
+              </a:rPr>
+              <a:t>Život i uloge — s posebnim osvrtom na ulogu Gvozdena u filmu „Lepa sela lepo gore“ (1996)</a:t>
+            </a:r>
+          </a:p>
+        </p:txBody>
+      </p:sp>
+      <p:sp>
+        <p:nvSpPr>
+          <p:cNvPr id="9" name="TextBox 8"/>
           <p:cNvSpPr txBox="1"/>
           <p:nvPr/>
         </p:nvSpPr>
         <p:spPr>
           <a:xfrm>
-            <a:off x="731520" y="2468880"/>
-            <a:ext cx="10698480" cy="1463040"/>
-          </a:xfrm>
-          <a:prstGeom prst="rect">
-            <a:avLst/>
-          </a:prstGeom>
-          <a:noFill/>
-        </p:spPr>
-        <p:txBody>
-          <a:bodyPr wrap="square" anchor="ctr">
-            <a:spAutoFit/>
-          </a:bodyPr>
-          <a:lstStyle/>
-          <a:p>
-            <a:pPr algn="ctr"/>
-            <a:r>
-              <a:rPr sz="4800" b="1" i="0">
-                <a:solidFill>
-                  <a:srgbClr val="FFFFFF"/>
-                </a:solidFill>
-                <a:latin typeface="Calibri"/>
-              </a:rPr>
-              <a:t>VELIMIR „BATA“ ŽIVOJINOVIĆ</a:t>
-            </a:r>
-          </a:p>
-        </p:txBody>
-      </p:sp>
-      <p:sp>
-        <p:nvSpPr>
-          <p:cNvPr id="8" name="TextBox 7"/>
-          <p:cNvSpPr txBox="1"/>
-          <p:nvPr/>
-        </p:nvSpPr>
-        <p:spPr>
-          <a:xfrm>
-            <a:off x="914400" y="4251960"/>
-            <a:ext cx="10332720" cy="1005840"/>
+            <a:off x="640080" y="5852160"/>
+            <a:ext cx="7040880" cy="548640"/>
           </a:xfrm>
           <a:prstGeom prst="rect">
             <a:avLst/>
@@ -3376,45 +3398,9 @@
           </a:bodyPr>
           <a:lstStyle/>
           <a:p>
-            <a:pPr algn="ctr"/>
-            <a:r>
-              <a:rPr sz="2200" b="0" i="1">
-                <a:solidFill>
-                  <a:srgbClr val="F4F1EA"/>
-                </a:solidFill>
-                <a:latin typeface="Calibri"/>
-              </a:rPr>
-              <a:t>Život i uloge — s posebnim osvrtom na ulogu Gvozdena
-u filmu „Lepa sela lepo gore“ (1996)</a:t>
-            </a:r>
-          </a:p>
-        </p:txBody>
-      </p:sp>
-      <p:sp>
-        <p:nvSpPr>
-          <p:cNvPr id="9" name="TextBox 8"/>
-          <p:cNvSpPr txBox="1"/>
-          <p:nvPr/>
-        </p:nvSpPr>
-        <p:spPr>
-          <a:xfrm>
-            <a:off x="914400" y="5897880"/>
-            <a:ext cx="10332720" cy="548640"/>
-          </a:xfrm>
-          <a:prstGeom prst="rect">
-            <a:avLst/>
-          </a:prstGeom>
-          <a:noFill/>
-        </p:spPr>
-        <p:txBody>
-          <a:bodyPr wrap="square" anchor="t">
-            <a:spAutoFit/>
-          </a:bodyPr>
-          <a:lstStyle/>
-          <a:p>
-            <a:pPr algn="ctr"/>
-            <a:r>
-              <a:rPr sz="1500" b="0" i="0">
+            <a:pPr algn="l"/>
+            <a:r>
+              <a:rPr sz="1400" b="0" i="0">
                 <a:solidFill>
                   <a:srgbClr val="C9A227"/>
                 </a:solidFill>
@@ -3711,7 +3697,7 @@
                 </a:solidFill>
                 <a:latin typeface="Calibri"/>
               </a:rPr>
-              <a:t>Time se stvara snažan kontrast: nekadašnji „heroj bratstva i jedinstva“ suočava se sa raspadom svega u šta je verovao.</a:t>
+              <a:t>Stvara se snažan kontrast: nekadašnji „heroj bratstva i jedinstva“ suočava se sa raspadom svega u šta je verovao.</a:t>
             </a:r>
           </a:p>
           <a:p>
@@ -3964,8 +3950,8 @@
         </p:nvSpPr>
         <p:spPr>
           <a:xfrm>
-            <a:off x="914400" y="1554480"/>
-            <a:ext cx="10332720" cy="4937760"/>
+            <a:off x="640080" y="1554480"/>
+            <a:ext cx="6675120" cy="4937760"/>
           </a:xfrm>
           <a:prstGeom prst="rect">
             <a:avLst/>
@@ -3983,11 +3969,11 @@
                 <a:spcPts val="0"/>
               </a:spcBef>
               <a:spcAft>
-                <a:spcPts val="1300"/>
+                <a:spcPts val="1100"/>
               </a:spcAft>
             </a:pPr>
             <a:r>
-              <a:rPr sz="1900" b="1">
+              <a:rPr sz="1800" b="1">
                 <a:solidFill>
                   <a:srgbClr val="B01E1E"/>
                 </a:solidFill>
@@ -3996,13 +3982,13 @@
               <a:t>•  </a:t>
             </a:r>
             <a:r>
-              <a:rPr sz="1900">
+              <a:rPr sz="1800">
                 <a:solidFill>
                   <a:srgbClr val="1A1A1A"/>
                 </a:solidFill>
                 <a:latin typeface="Calibri"/>
               </a:rPr>
-              <a:t>Tokom karijere osvojio je brojne nagrade, među kojima i prestižne Zlatne arene na filmskom festivalu u Puli.</a:t>
+              <a:t>Osvojio je brojne nagrade, među kojima i prestižne Zlatne arene na festivalu u Puli.</a:t>
             </a:r>
           </a:p>
           <a:p>
@@ -4011,11 +3997,11 @@
                 <a:spcPts val="0"/>
               </a:spcBef>
               <a:spcAft>
-                <a:spcPts val="1300"/>
+                <a:spcPts val="1100"/>
               </a:spcAft>
             </a:pPr>
             <a:r>
-              <a:rPr sz="1900" b="1">
+              <a:rPr sz="1800" b="1">
                 <a:solidFill>
                   <a:srgbClr val="B01E1E"/>
                 </a:solidFill>
@@ -4024,7 +4010,7 @@
               <a:t>•  </a:t>
             </a:r>
             <a:r>
-              <a:rPr sz="1900">
+              <a:rPr sz="1800">
                 <a:solidFill>
                   <a:srgbClr val="1A1A1A"/>
                 </a:solidFill>
@@ -4039,11 +4025,11 @@
                 <a:spcPts val="0"/>
               </a:spcBef>
               <a:spcAft>
-                <a:spcPts val="1300"/>
+                <a:spcPts val="1100"/>
               </a:spcAft>
             </a:pPr>
             <a:r>
-              <a:rPr sz="1900" b="1">
+              <a:rPr sz="1800" b="1">
                 <a:solidFill>
                   <a:srgbClr val="B01E1E"/>
                 </a:solidFill>
@@ -4052,7 +4038,7 @@
               <a:t>•  </a:t>
             </a:r>
             <a:r>
-              <a:rPr sz="1900">
+              <a:rPr sz="1800">
                 <a:solidFill>
                   <a:srgbClr val="1A1A1A"/>
                 </a:solidFill>
@@ -4067,11 +4053,11 @@
                 <a:spcPts val="0"/>
               </a:spcBef>
               <a:spcAft>
-                <a:spcPts val="1300"/>
+                <a:spcPts val="1100"/>
               </a:spcAft>
             </a:pPr>
             <a:r>
-              <a:rPr sz="1900" b="1">
+              <a:rPr sz="1800" b="1">
                 <a:solidFill>
                   <a:srgbClr val="B01E1E"/>
                 </a:solidFill>
@@ -4080,13 +4066,13 @@
               <a:t>•  </a:t>
             </a:r>
             <a:r>
-              <a:rPr sz="1900">
+              <a:rPr sz="1800">
                 <a:solidFill>
                   <a:srgbClr val="1A1A1A"/>
                 </a:solidFill>
                 <a:latin typeface="Calibri"/>
               </a:rPr>
-              <a:t>Preminuo je 22. maja 2016. godine u Beogradu, u 83. godini života.</a:t>
+              <a:t>Preminuo je 22. maja 2016. u Beogradu, u 83. godini.</a:t>
             </a:r>
           </a:p>
           <a:p>
@@ -4095,11 +4081,11 @@
                 <a:spcPts val="0"/>
               </a:spcBef>
               <a:spcAft>
-                <a:spcPts val="1300"/>
+                <a:spcPts val="1100"/>
               </a:spcAft>
             </a:pPr>
             <a:r>
-              <a:rPr sz="1900" b="1">
+              <a:rPr sz="1800" b="1">
                 <a:solidFill>
                   <a:srgbClr val="B01E1E"/>
                 </a:solidFill>
@@ -4108,13 +4094,143 @@
               <a:t>•  </a:t>
             </a:r>
             <a:r>
-              <a:rPr sz="1900">
+              <a:rPr sz="1800">
                 <a:solidFill>
                   <a:srgbClr val="1A1A1A"/>
                 </a:solidFill>
                 <a:latin typeface="Calibri"/>
               </a:rPr>
-              <a:t>Njegovi filmovi i danas se rado gledaju, a lik i delo ostaju deo kulturnog nasleđa regiona.</a:t>
+              <a:t>Njemu u čast izdata je i poštanska marka; filmovi mu se i danas rado gledaju.</a:t>
+            </a:r>
+          </a:p>
+        </p:txBody>
+      </p:sp>
+      <p:pic>
+        <p:nvPicPr>
+          <p:cNvPr id="7" name="Picture 6" descr="pula.jpg"/>
+          <p:cNvPicPr>
+            <a:picLocks noChangeAspect="1"/>
+          </p:cNvPicPr>
+          <p:nvPr/>
+        </p:nvPicPr>
+        <p:blipFill>
+          <a:blip r:embed="rId2"/>
+          <a:srcRect l="1201" r="1201"/>
+          <a:stretch>
+            <a:fillRect/>
+          </a:stretch>
+        </p:blipFill>
+        <p:spPr>
+          <a:xfrm>
+            <a:off x="7680960" y="1600200"/>
+            <a:ext cx="4023360" cy="2331720"/>
+          </a:xfrm>
+          <a:prstGeom prst="rect">
+            <a:avLst/>
+          </a:prstGeom>
+          <a:ln w="38100">
+            <a:solidFill>
+              <a:srgbClr val="C9A227"/>
+            </a:solidFill>
+          </a:ln>
+        </p:spPr>
+      </p:pic>
+      <p:sp>
+        <p:nvSpPr>
+          <p:cNvPr id="8" name="TextBox 7"/>
+          <p:cNvSpPr txBox="1"/>
+          <p:nvPr/>
+        </p:nvSpPr>
+        <p:spPr>
+          <a:xfrm>
+            <a:off x="7680960" y="3950208"/>
+            <a:ext cx="4023360" cy="274320"/>
+          </a:xfrm>
+          <a:prstGeom prst="rect">
+            <a:avLst/>
+          </a:prstGeom>
+          <a:noFill/>
+        </p:spPr>
+        <p:txBody>
+          <a:bodyPr wrap="square" anchor="t">
+            <a:spAutoFit/>
+          </a:bodyPr>
+          <a:lstStyle/>
+          <a:p>
+            <a:pPr algn="ctr"/>
+            <a:r>
+              <a:rPr sz="900" b="0" i="1">
+                <a:solidFill>
+                  <a:srgbClr val="3D3D3D"/>
+                </a:solidFill>
+                <a:latin typeface="Calibri"/>
+              </a:rPr>
+              <a:t>Arena u Puli — dom filmskog festivala</a:t>
+            </a:r>
+          </a:p>
+        </p:txBody>
+      </p:sp>
+      <p:pic>
+        <p:nvPicPr>
+          <p:cNvPr id="9" name="Picture 8" descr="marka.jpg"/>
+          <p:cNvPicPr>
+            <a:picLocks noChangeAspect="1"/>
+          </p:cNvPicPr>
+          <p:nvPr/>
+        </p:nvPicPr>
+        <p:blipFill>
+          <a:blip r:embed="rId3"/>
+          <a:srcRect t="32277" b="32277"/>
+          <a:stretch>
+            <a:fillRect/>
+          </a:stretch>
+        </p:blipFill>
+        <p:spPr>
+          <a:xfrm>
+            <a:off x="7680960" y="4343400"/>
+            <a:ext cx="4023360" cy="1920240"/>
+          </a:xfrm>
+          <a:prstGeom prst="rect">
+            <a:avLst/>
+          </a:prstGeom>
+          <a:ln w="38100">
+            <a:solidFill>
+              <a:srgbClr val="C9A227"/>
+            </a:solidFill>
+          </a:ln>
+        </p:spPr>
+      </p:pic>
+      <p:sp>
+        <p:nvSpPr>
+          <p:cNvPr id="10" name="TextBox 9"/>
+          <p:cNvSpPr txBox="1"/>
+          <p:nvPr/>
+        </p:nvSpPr>
+        <p:spPr>
+          <a:xfrm>
+            <a:off x="7680960" y="6291072"/>
+            <a:ext cx="4023360" cy="274320"/>
+          </a:xfrm>
+          <a:prstGeom prst="rect">
+            <a:avLst/>
+          </a:prstGeom>
+          <a:noFill/>
+        </p:spPr>
+        <p:txBody>
+          <a:bodyPr wrap="square" anchor="t">
+            <a:spAutoFit/>
+          </a:bodyPr>
+          <a:lstStyle/>
+          <a:p>
+            <a:pPr algn="ctr"/>
+            <a:r>
+              <a:rPr sz="900" b="0" i="1">
+                <a:solidFill>
+                  <a:srgbClr val="3D3D3D"/>
+                </a:solidFill>
+                <a:latin typeface="Calibri"/>
+              </a:rPr>
+              <a:t>Poštanska marka Srbije (2023)</a:t>
             </a:r>
           </a:p>
         </p:txBody>
@@ -4437,8 +4553,8 @@
         </p:nvSpPr>
         <p:spPr>
           <a:xfrm>
-            <a:off x="0" y="2743200"/>
-            <a:ext cx="12191695" cy="50000"/>
+            <a:off x="2286000" y="2468880"/>
+            <a:ext cx="7589520" cy="50000"/>
           </a:xfrm>
           <a:prstGeom prst="rect">
             <a:avLst/>
@@ -4481,7 +4597,7 @@
         </p:nvSpPr>
         <p:spPr>
           <a:xfrm>
-            <a:off x="914400" y="2194560"/>
+            <a:off x="914400" y="1737360"/>
             <a:ext cx="10332720" cy="1097280"/>
           </a:xfrm>
           <a:prstGeom prst="rect">
@@ -4516,8 +4632,8 @@
         </p:nvSpPr>
         <p:spPr>
           <a:xfrm>
-            <a:off x="914400" y="3383280"/>
-            <a:ext cx="10332720" cy="731520"/>
+            <a:off x="914400" y="2834640"/>
+            <a:ext cx="10332720" cy="640080"/>
           </a:xfrm>
           <a:prstGeom prst="rect">
             <a:avLst/>
@@ -4551,8 +4667,8 @@
         </p:nvSpPr>
         <p:spPr>
           <a:xfrm>
-            <a:off x="914400" y="5852160"/>
-            <a:ext cx="10332720" cy="548640"/>
+            <a:off x="914400" y="4023360"/>
+            <a:ext cx="10332720" cy="457200"/>
           </a:xfrm>
           <a:prstGeom prst="rect">
             <a:avLst/>
@@ -4567,13 +4683,118 @@
           <a:p>
             <a:pPr algn="ctr"/>
             <a:r>
+              <a:rPr sz="1500" b="1" i="0">
+                <a:solidFill>
+                  <a:srgbClr val="C9A227"/>
+                </a:solidFill>
+                <a:latin typeface="Calibri"/>
+              </a:rPr>
+              <a:t>Izvori teksta:</a:t>
+            </a:r>
+          </a:p>
+        </p:txBody>
+      </p:sp>
+      <p:sp>
+        <p:nvSpPr>
+          <p:cNvPr id="6" name="TextBox 5"/>
+          <p:cNvSpPr txBox="1"/>
+          <p:nvPr/>
+        </p:nvSpPr>
+        <p:spPr>
+          <a:xfrm>
+            <a:off x="1371600" y="4389120"/>
+            <a:ext cx="9418320" cy="457200"/>
+          </a:xfrm>
+          <a:prstGeom prst="rect">
+            <a:avLst/>
+          </a:prstGeom>
+          <a:noFill/>
+        </p:spPr>
+        <p:txBody>
+          <a:bodyPr wrap="square" anchor="t">
+            <a:spAutoFit/>
+          </a:bodyPr>
+          <a:lstStyle/>
+          <a:p>
+            <a:pPr algn="ctr"/>
+            <a:r>
               <a:rPr sz="1300" b="0" i="0">
                 <a:solidFill>
                   <a:srgbClr val="F4F1EA"/>
                 </a:solidFill>
                 <a:latin typeface="Calibri"/>
               </a:rPr>
-              <a:t>Izvori: Wikipedia, baze podataka o filmu, dostupni filmski i biografski materijali</a:t>
+              <a:t>Wikipedia i dostupni filmski i biografski materijali</a:t>
+            </a:r>
+          </a:p>
+        </p:txBody>
+      </p:sp>
+      <p:sp>
+        <p:nvSpPr>
+          <p:cNvPr id="7" name="TextBox 6"/>
+          <p:cNvSpPr txBox="1"/>
+          <p:nvPr/>
+        </p:nvSpPr>
+        <p:spPr>
+          <a:xfrm>
+            <a:off x="914400" y="5029200"/>
+            <a:ext cx="10332720" cy="457200"/>
+          </a:xfrm>
+          <a:prstGeom prst="rect">
+            <a:avLst/>
+          </a:prstGeom>
+          <a:noFill/>
+        </p:spPr>
+        <p:txBody>
+          <a:bodyPr wrap="square" anchor="t">
+            <a:spAutoFit/>
+          </a:bodyPr>
+          <a:lstStyle/>
+          <a:p>
+            <a:pPr algn="ctr"/>
+            <a:r>
+              <a:rPr sz="1500" b="1" i="0">
+                <a:solidFill>
+                  <a:srgbClr val="C9A227"/>
+                </a:solidFill>
+                <a:latin typeface="Calibri"/>
+              </a:rPr>
+              <a:t>Fotografije:</a:t>
+            </a:r>
+          </a:p>
+        </p:txBody>
+      </p:sp>
+      <p:sp>
+        <p:nvSpPr>
+          <p:cNvPr id="8" name="TextBox 7"/>
+          <p:cNvSpPr txBox="1"/>
+          <p:nvPr/>
+        </p:nvSpPr>
+        <p:spPr>
+          <a:xfrm>
+            <a:off x="1097280" y="5394960"/>
+            <a:ext cx="9966960" cy="914400"/>
+          </a:xfrm>
+          <a:prstGeom prst="rect">
+            <a:avLst/>
+          </a:prstGeom>
+          <a:noFill/>
+        </p:spPr>
+        <p:txBody>
+          <a:bodyPr wrap="square" anchor="t">
+            <a:spAutoFit/>
+          </a:bodyPr>
+          <a:lstStyle/>
+          <a:p>
+            <a:pPr algn="ctr"/>
+            <a:r>
+              <a:rPr sz="1100" b="0" i="0">
+                <a:solidFill>
+                  <a:srgbClr val="F4F1EA"/>
+                </a:solidFill>
+                <a:latin typeface="Calibri"/>
+              </a:rPr>
+              <a:t>Wikimedia Commons — portreti i fotografija iz Skupštine: Medija centar Beograd / Stevan Kragujević (CC BY-SA 3.0); Kosmaj i Arena u Puli (CC BY-SA); poštanska marka: Pošta Srbije (javno vlasništvo).</a:t>
             </a:r>
           </a:p>
         </p:txBody>
@@ -5258,7 +5479,7 @@
         <p:spPr>
           <a:xfrm>
             <a:off x="640080" y="1554480"/>
-            <a:ext cx="6766560" cy="4937760"/>
+            <a:ext cx="6675120" cy="4937760"/>
           </a:xfrm>
           <a:prstGeom prst="rect">
             <a:avLst/>
@@ -5276,11 +5497,11 @@
                 <a:spcPts val="0"/>
               </a:spcBef>
               <a:spcAft>
-                <a:spcPts val="1200"/>
+                <a:spcPts val="1100"/>
               </a:spcAft>
             </a:pPr>
             <a:r>
-              <a:rPr sz="1900" b="1">
+              <a:rPr sz="1800" b="1">
                 <a:solidFill>
                   <a:srgbClr val="B01E1E"/>
                 </a:solidFill>
@@ -5289,7 +5510,7 @@
               <a:t>•  </a:t>
             </a:r>
             <a:r>
-              <a:rPr sz="1900">
+              <a:rPr sz="1800">
                 <a:solidFill>
                   <a:srgbClr val="1A1A1A"/>
                 </a:solidFill>
@@ -5304,11 +5525,11 @@
                 <a:spcPts val="0"/>
               </a:spcBef>
               <a:spcAft>
-                <a:spcPts val="1200"/>
+                <a:spcPts val="1100"/>
               </a:spcAft>
             </a:pPr>
             <a:r>
-              <a:rPr sz="1900" b="1">
+              <a:rPr sz="1800" b="1">
                 <a:solidFill>
                   <a:srgbClr val="B01E1E"/>
                 </a:solidFill>
@@ -5317,7 +5538,7 @@
               <a:t>•  </a:t>
             </a:r>
             <a:r>
-              <a:rPr sz="1900">
+              <a:rPr sz="1800">
                 <a:solidFill>
                   <a:srgbClr val="1A1A1A"/>
                 </a:solidFill>
@@ -5332,11 +5553,11 @@
                 <a:spcPts val="0"/>
               </a:spcBef>
               <a:spcAft>
-                <a:spcPts val="1200"/>
+                <a:spcPts val="1100"/>
               </a:spcAft>
             </a:pPr>
             <a:r>
-              <a:rPr sz="1900" b="1">
+              <a:rPr sz="1800" b="1">
                 <a:solidFill>
                   <a:srgbClr val="B01E1E"/>
                 </a:solidFill>
@@ -5345,13 +5566,13 @@
               <a:t>•  </a:t>
             </a:r>
             <a:r>
-              <a:rPr sz="1900">
+              <a:rPr sz="1800">
                 <a:solidFill>
                   <a:srgbClr val="1A1A1A"/>
                 </a:solidFill>
                 <a:latin typeface="Calibri"/>
               </a:rPr>
-              <a:t>Postao je prepoznatljiv kao simbol „partizanskih“ ratnih filmova i otelotvorenje hrabrog, narodnog junaka.</a:t>
+              <a:t>Postao je prepoznatljiv kao simbol „partizanskih“ ratnih filmova i otelotvorenje narodnog junaka.</a:t>
             </a:r>
           </a:p>
           <a:p>
@@ -5360,11 +5581,11 @@
                 <a:spcPts val="0"/>
               </a:spcBef>
               <a:spcAft>
-                <a:spcPts val="1200"/>
+                <a:spcPts val="1100"/>
               </a:spcAft>
             </a:pPr>
             <a:r>
-              <a:rPr sz="1900" b="1">
+              <a:rPr sz="1800" b="1">
                 <a:solidFill>
                   <a:srgbClr val="B01E1E"/>
                 </a:solidFill>
@@ -5373,7 +5594,7 @@
               <a:t>•  </a:t>
             </a:r>
             <a:r>
-              <a:rPr sz="1900">
+              <a:rPr sz="1800">
                 <a:solidFill>
                   <a:srgbClr val="1A1A1A"/>
                 </a:solidFill>
@@ -5388,11 +5609,11 @@
                 <a:spcPts val="0"/>
               </a:spcBef>
               <a:spcAft>
-                <a:spcPts val="1200"/>
+                <a:spcPts val="1100"/>
               </a:spcAft>
             </a:pPr>
             <a:r>
-              <a:rPr sz="1900" b="1">
+              <a:rPr sz="1800" b="1">
                 <a:solidFill>
                   <a:srgbClr val="B01E1E"/>
                 </a:solidFill>
@@ -5401,7 +5622,7 @@
               <a:t>•  </a:t>
             </a:r>
             <a:r>
-              <a:rPr sz="1900">
+              <a:rPr sz="1800">
                 <a:solidFill>
                   <a:srgbClr val="1A1A1A"/>
                 </a:solidFill>
@@ -5420,8 +5641,8 @@
         </p:nvSpPr>
         <p:spPr>
           <a:xfrm>
-            <a:off x="7818120" y="7680960"/>
-            <a:ext cx="3931920" cy="4663440"/>
+            <a:off x="7589520" y="1554480"/>
+            <a:ext cx="4114800" cy="2331720"/>
           </a:xfrm>
           <a:prstGeom prst="rect">
             <a:avLst/>
@@ -5464,8 +5685,8 @@
         </p:nvSpPr>
         <p:spPr>
           <a:xfrm>
-            <a:off x="8001000" y="1783080"/>
-            <a:ext cx="3566160" cy="548640"/>
+            <a:off x="7818120" y="1737360"/>
+            <a:ext cx="3657600" cy="457200"/>
           </a:xfrm>
           <a:prstGeom prst="rect">
             <a:avLst/>
@@ -5480,7 +5701,7 @@
           <a:p>
             <a:pPr algn="l"/>
             <a:r>
-              <a:rPr sz="1800" b="1" i="0">
+              <a:rPr sz="1700" b="1" i="0">
                 <a:solidFill>
                   <a:srgbClr val="C9A227"/>
                 </a:solidFill>
@@ -5499,8 +5720,8 @@
         </p:nvSpPr>
         <p:spPr>
           <a:xfrm>
-            <a:off x="8001000" y="2423160"/>
-            <a:ext cx="3566160" cy="3657600"/>
+            <a:off x="7818120" y="2286000"/>
+            <a:ext cx="3657600" cy="1645920"/>
           </a:xfrm>
           <a:prstGeom prst="rect">
             <a:avLst/>
@@ -5518,11 +5739,11 @@
                 <a:spcPts val="0"/>
               </a:spcBef>
               <a:spcAft>
-                <a:spcPts val="1200"/>
+                <a:spcPts val="800"/>
               </a:spcAft>
             </a:pPr>
             <a:r>
-              <a:rPr sz="1500" b="1">
+              <a:rPr sz="1300" b="1">
                 <a:solidFill>
                   <a:srgbClr val="C9A227"/>
                 </a:solidFill>
@@ -5531,7 +5752,7 @@
               <a:t>•  </a:t>
             </a:r>
             <a:r>
-              <a:rPr sz="1500">
+              <a:rPr sz="1300">
                 <a:solidFill>
                   <a:srgbClr val="FFFFFF"/>
                 </a:solidFill>
@@ -5546,11 +5767,11 @@
                 <a:spcPts val="0"/>
               </a:spcBef>
               <a:spcAft>
-                <a:spcPts val="1200"/>
+                <a:spcPts val="800"/>
               </a:spcAft>
             </a:pPr>
             <a:r>
-              <a:rPr sz="1500" b="1">
+              <a:rPr sz="1300" b="1">
                 <a:solidFill>
                   <a:srgbClr val="C9A227"/>
                 </a:solidFill>
@@ -5559,7 +5780,7 @@
               <a:t>•  </a:t>
             </a:r>
             <a:r>
-              <a:rPr sz="1500">
+              <a:rPr sz="1300">
                 <a:solidFill>
                   <a:srgbClr val="FFFFFF"/>
                 </a:solidFill>
@@ -5574,11 +5795,11 @@
                 <a:spcPts val="0"/>
               </a:spcBef>
               <a:spcAft>
-                <a:spcPts val="1200"/>
+                <a:spcPts val="800"/>
               </a:spcAft>
             </a:pPr>
             <a:r>
-              <a:rPr sz="1500" b="1">
+              <a:rPr sz="1300" b="1">
                 <a:solidFill>
                   <a:srgbClr val="C9A227"/>
                 </a:solidFill>
@@ -5587,7 +5808,7 @@
               <a:t>•  </a:t>
             </a:r>
             <a:r>
-              <a:rPr sz="1500">
+              <a:rPr sz="1300">
                 <a:solidFill>
                   <a:srgbClr val="FFFFFF"/>
                 </a:solidFill>
@@ -5602,11 +5823,11 @@
                 <a:spcPts val="0"/>
               </a:spcBef>
               <a:spcAft>
-                <a:spcPts val="1200"/>
+                <a:spcPts val="800"/>
               </a:spcAft>
             </a:pPr>
             <a:r>
-              <a:rPr sz="1500" b="1">
+              <a:rPr sz="1300" b="1">
                 <a:solidFill>
                   <a:srgbClr val="C9A227"/>
                 </a:solidFill>
@@ -5615,7 +5836,7 @@
               <a:t>•  </a:t>
             </a:r>
             <a:r>
-              <a:rPr sz="1500">
+              <a:rPr sz="1300">
                 <a:solidFill>
                   <a:srgbClr val="FFFFFF"/>
                 </a:solidFill>
@@ -5624,36 +5845,38 @@
               <a:t>Preminuo: 22. maj 2016, Beograd</a:t>
             </a:r>
           </a:p>
-          <a:p>
-            <a:pPr>
-              <a:spcBef>
-                <a:spcPts val="0"/>
-              </a:spcBef>
-              <a:spcAft>
-                <a:spcPts val="1200"/>
-              </a:spcAft>
-            </a:pPr>
-            <a:r>
-              <a:rPr sz="1500" b="1">
-                <a:solidFill>
-                  <a:srgbClr val="C9A227"/>
-                </a:solidFill>
-                <a:latin typeface="Calibri"/>
-              </a:rPr>
-              <a:t>•  </a:t>
-            </a:r>
-            <a:r>
-              <a:rPr sz="1500">
-                <a:solidFill>
-                  <a:srgbClr val="FFFFFF"/>
-                </a:solidFill>
-                <a:latin typeface="Calibri"/>
-              </a:rPr>
-              <a:t>Zanimanje: glumac, političar</a:t>
-            </a:r>
-          </a:p>
-        </p:txBody>
-      </p:sp>
+        </p:txBody>
+      </p:sp>
+      <p:pic>
+        <p:nvPicPr>
+          <p:cNvPr id="10" name="Picture 9" descr="bata2.jpg"/>
+          <p:cNvPicPr>
+            <a:picLocks noChangeAspect="1"/>
+          </p:cNvPicPr>
+          <p:nvPr/>
+        </p:nvPicPr>
+        <p:blipFill>
+          <a:blip r:embed="rId2"/>
+          <a:srcRect t="8170" b="8170"/>
+          <a:stretch>
+            <a:fillRect/>
+          </a:stretch>
+        </p:blipFill>
+        <p:spPr>
+          <a:xfrm>
+            <a:off x="7589520" y="4069080"/>
+            <a:ext cx="4114800" cy="2286000"/>
+          </a:xfrm>
+          <a:prstGeom prst="rect">
+            <a:avLst/>
+          </a:prstGeom>
+          <a:ln w="38100">
+            <a:solidFill>
+              <a:srgbClr val="C9A227"/>
+            </a:solidFill>
+          </a:ln>
+        </p:spPr>
+      </p:pic>
     </p:spTree>
   </p:cSld>
   <p:clrMapOvr>
@@ -5846,8 +6069,8 @@
         </p:nvSpPr>
         <p:spPr>
           <a:xfrm>
-            <a:off x="914400" y="1554480"/>
-            <a:ext cx="10332720" cy="4937760"/>
+            <a:off x="640080" y="1554480"/>
+            <a:ext cx="6766560" cy="4937760"/>
           </a:xfrm>
           <a:prstGeom prst="rect">
             <a:avLst/>
@@ -5865,11 +6088,11 @@
                 <a:spcPts val="0"/>
               </a:spcBef>
               <a:spcAft>
-                <a:spcPts val="1300"/>
+                <a:spcPts val="1200"/>
               </a:spcAft>
             </a:pPr>
             <a:r>
-              <a:rPr sz="1900" b="1">
+              <a:rPr sz="1800" b="1">
                 <a:solidFill>
                   <a:srgbClr val="B01E1E"/>
                 </a:solidFill>
@@ -5878,13 +6101,13 @@
               <a:t>•  </a:t>
             </a:r>
             <a:r>
-              <a:rPr sz="1900">
+              <a:rPr sz="1800">
                 <a:solidFill>
                   <a:srgbClr val="1A1A1A"/>
                 </a:solidFill>
                 <a:latin typeface="Calibri"/>
               </a:rPr>
-              <a:t>Rođen je 5. juna 1933. godine u selu Koraćica, u podnožju planine Kosmaj, blizu Mladenovca.</a:t>
+              <a:t>Rođen je 5. juna 1933. u selu Koraćica, u podnožju planine Kosmaj, blizu Mladenovca.</a:t>
             </a:r>
           </a:p>
           <a:p>
@@ -5893,11 +6116,11 @@
                 <a:spcPts val="0"/>
               </a:spcBef>
               <a:spcAft>
-                <a:spcPts val="1300"/>
+                <a:spcPts val="1200"/>
               </a:spcAft>
             </a:pPr>
             <a:r>
-              <a:rPr sz="1900" b="1">
+              <a:rPr sz="1800" b="1">
                 <a:solidFill>
                   <a:srgbClr val="B01E1E"/>
                 </a:solidFill>
@@ -5906,7 +6129,7 @@
               <a:t>•  </a:t>
             </a:r>
             <a:r>
-              <a:rPr sz="1900">
+              <a:rPr sz="1800">
                 <a:solidFill>
                   <a:srgbClr val="1A1A1A"/>
                 </a:solidFill>
@@ -5921,11 +6144,11 @@
                 <a:spcPts val="0"/>
               </a:spcBef>
               <a:spcAft>
-                <a:spcPts val="1300"/>
+                <a:spcPts val="1200"/>
               </a:spcAft>
             </a:pPr>
             <a:r>
-              <a:rPr sz="1900" b="1">
+              <a:rPr sz="1800" b="1">
                 <a:solidFill>
                   <a:srgbClr val="B01E1E"/>
                 </a:solidFill>
@@ -5934,7 +6157,7 @@
               <a:t>•  </a:t>
             </a:r>
             <a:r>
-              <a:rPr sz="1900">
+              <a:rPr sz="1800">
                 <a:solidFill>
                   <a:srgbClr val="1A1A1A"/>
                 </a:solidFill>
@@ -5949,11 +6172,11 @@
                 <a:spcPts val="0"/>
               </a:spcBef>
               <a:spcAft>
-                <a:spcPts val="1300"/>
+                <a:spcPts val="1200"/>
               </a:spcAft>
             </a:pPr>
             <a:r>
-              <a:rPr sz="1900" b="1">
+              <a:rPr sz="1800" b="1">
                 <a:solidFill>
                   <a:srgbClr val="B01E1E"/>
                 </a:solidFill>
@@ -5962,13 +6185,13 @@
               <a:t>•  </a:t>
             </a:r>
             <a:r>
-              <a:rPr sz="1900">
+              <a:rPr sz="1800">
                 <a:solidFill>
                   <a:srgbClr val="1A1A1A"/>
                 </a:solidFill>
                 <a:latin typeface="Calibri"/>
               </a:rPr>
-              <a:t>Diplomirao je na Akademiji za pozorišnu umetnost u Beogradu (danas Fakultet dramskih umetnosti).</a:t>
+              <a:t>Diplomirao je na Akademiji za pozorišnu umetnost u Beogradu.</a:t>
             </a:r>
           </a:p>
           <a:p>
@@ -5977,11 +6200,11 @@
                 <a:spcPts val="0"/>
               </a:spcBef>
               <a:spcAft>
-                <a:spcPts val="1300"/>
+                <a:spcPts val="1200"/>
               </a:spcAft>
             </a:pPr>
             <a:r>
-              <a:rPr sz="1900" b="1">
+              <a:rPr sz="1800" b="1">
                 <a:solidFill>
                   <a:srgbClr val="B01E1E"/>
                 </a:solidFill>
@@ -5990,7 +6213,7 @@
               <a:t>•  </a:t>
             </a:r>
             <a:r>
-              <a:rPr sz="1900">
+              <a:rPr sz="1800">
                 <a:solidFill>
                   <a:srgbClr val="1A1A1A"/>
                 </a:solidFill>
@@ -5999,32 +6222,69 @@
               <a:t>Karijeru je započeo u pozorištu, a ubrzo prešao na film, gde je stekao najveću slavu.</a:t>
             </a:r>
           </a:p>
-          <a:p>
-            <a:pPr>
-              <a:spcBef>
-                <a:spcPts val="0"/>
-              </a:spcBef>
-              <a:spcAft>
-                <a:spcPts val="1300"/>
-              </a:spcAft>
-            </a:pPr>
-            <a:r>
-              <a:rPr sz="1900" b="1">
-                <a:solidFill>
-                  <a:srgbClr val="B01E1E"/>
-                </a:solidFill>
-                <a:latin typeface="Calibri"/>
-              </a:rPr>
-              <a:t>•  </a:t>
-            </a:r>
-            <a:r>
-              <a:rPr sz="1900">
-                <a:solidFill>
-                  <a:srgbClr val="1A1A1A"/>
-                </a:solidFill>
-                <a:latin typeface="Calibri"/>
-              </a:rPr>
-              <a:t>Bio je član ansambla beogradskih pozorišta i jedan od najtraženijih glumaca svoje generacije.</a:t>
+        </p:txBody>
+      </p:sp>
+      <p:pic>
+        <p:nvPicPr>
+          <p:cNvPr id="7" name="Picture 6" descr="kosmaj.jpg"/>
+          <p:cNvPicPr>
+            <a:picLocks noChangeAspect="1"/>
+          </p:cNvPicPr>
+          <p:nvPr/>
+        </p:nvPicPr>
+        <p:blipFill>
+          <a:blip r:embed="rId2"/>
+          <a:srcRect l="24971" r="24971"/>
+          <a:stretch>
+            <a:fillRect/>
+          </a:stretch>
+        </p:blipFill>
+        <p:spPr>
+          <a:xfrm>
+            <a:off x="7680960" y="1554480"/>
+            <a:ext cx="4023360" cy="4206240"/>
+          </a:xfrm>
+          <a:prstGeom prst="rect">
+            <a:avLst/>
+          </a:prstGeom>
+          <a:ln w="38100">
+            <a:solidFill>
+              <a:srgbClr val="C9A227"/>
+            </a:solidFill>
+          </a:ln>
+        </p:spPr>
+      </p:pic>
+      <p:sp>
+        <p:nvSpPr>
+          <p:cNvPr id="8" name="TextBox 7"/>
+          <p:cNvSpPr txBox="1"/>
+          <p:nvPr/>
+        </p:nvSpPr>
+        <p:spPr>
+          <a:xfrm>
+            <a:off x="7680960" y="5806440"/>
+            <a:ext cx="4023360" cy="274320"/>
+          </a:xfrm>
+          <a:prstGeom prst="rect">
+            <a:avLst/>
+          </a:prstGeom>
+          <a:noFill/>
+        </p:spPr>
+        <p:txBody>
+          <a:bodyPr wrap="square" anchor="t">
+            <a:spAutoFit/>
+          </a:bodyPr>
+          <a:lstStyle/>
+          <a:p>
+            <a:pPr algn="ctr"/>
+            <a:r>
+              <a:rPr sz="900" b="0" i="1">
+                <a:solidFill>
+                  <a:srgbClr val="3D3D3D"/>
+                </a:solidFill>
+                <a:latin typeface="Calibri"/>
+              </a:rPr>
+              <a:t>Planina Kosmaj, kraj odakle potiče</a:t>
             </a:r>
           </a:p>
         </p:txBody>
@@ -6221,8 +6481,8 @@
         </p:nvSpPr>
         <p:spPr>
           <a:xfrm>
-            <a:off x="914400" y="1508760"/>
-            <a:ext cx="10332720" cy="5029200"/>
+            <a:off x="640080" y="1508760"/>
+            <a:ext cx="6858000" cy="5029200"/>
           </a:xfrm>
           <a:prstGeom prst="rect">
             <a:avLst/>
@@ -6240,11 +6500,11 @@
                 <a:spcPts val="0"/>
               </a:spcBef>
               <a:spcAft>
-                <a:spcPts val="900"/>
+                <a:spcPts val="800"/>
               </a:spcAft>
             </a:pPr>
             <a:r>
-              <a:rPr sz="1800" b="1">
+              <a:rPr sz="1700" b="1">
                 <a:solidFill>
                   <a:srgbClr val="B01E1E"/>
                 </a:solidFill>
@@ -6253,13 +6513,13 @@
               <a:t>•  </a:t>
             </a:r>
             <a:r>
-              <a:rPr sz="1800">
+              <a:rPr sz="1700">
                 <a:solidFill>
                   <a:srgbClr val="1A1A1A"/>
                 </a:solidFill>
                 <a:latin typeface="Calibri"/>
               </a:rPr>
-              <a:t>Najveću popularnost stekao je u partizanskim ratnim filmovima, gde je tumačio hrabre borce i komandante:</a:t>
+              <a:t>Najveću popularnost stekao je u partizanskim ratnim filmovima, tumačeći hrabre borce i komandante:</a:t>
             </a:r>
           </a:p>
           <a:p>
@@ -6268,11 +6528,11 @@
                 <a:spcPts val="0"/>
               </a:spcBef>
               <a:spcAft>
-                <a:spcPts val="900"/>
+                <a:spcPts val="800"/>
               </a:spcAft>
             </a:pPr>
             <a:r>
-              <a:rPr sz="1800" b="1">
+              <a:rPr sz="1700" b="1">
                 <a:solidFill>
                   <a:srgbClr val="C9A227"/>
                 </a:solidFill>
@@ -6281,7 +6541,7 @@
               <a:t>–  </a:t>
             </a:r>
             <a:r>
-              <a:rPr sz="1600">
+              <a:rPr sz="1500">
                 <a:solidFill>
                   <a:srgbClr val="1A1A1A"/>
                 </a:solidFill>
@@ -6296,11 +6556,11 @@
                 <a:spcPts val="0"/>
               </a:spcBef>
               <a:spcAft>
-                <a:spcPts val="900"/>
+                <a:spcPts val="800"/>
               </a:spcAft>
             </a:pPr>
             <a:r>
-              <a:rPr sz="1800" b="1">
+              <a:rPr sz="1700" b="1">
                 <a:solidFill>
                   <a:srgbClr val="C9A227"/>
                 </a:solidFill>
@@ -6309,7 +6569,7 @@
               <a:t>–  </a:t>
             </a:r>
             <a:r>
-              <a:rPr sz="1600">
+              <a:rPr sz="1500">
                 <a:solidFill>
                   <a:srgbClr val="1A1A1A"/>
                 </a:solidFill>
@@ -6324,11 +6584,11 @@
                 <a:spcPts val="0"/>
               </a:spcBef>
               <a:spcAft>
-                <a:spcPts val="900"/>
+                <a:spcPts val="800"/>
               </a:spcAft>
             </a:pPr>
             <a:r>
-              <a:rPr sz="1800" b="1">
+              <a:rPr sz="1700" b="1">
                 <a:solidFill>
                   <a:srgbClr val="C9A227"/>
                 </a:solidFill>
@@ -6337,7 +6597,7 @@
               <a:t>–  </a:t>
             </a:r>
             <a:r>
-              <a:rPr sz="1600">
+              <a:rPr sz="1500">
                 <a:solidFill>
                   <a:srgbClr val="1A1A1A"/>
                 </a:solidFill>
@@ -6352,11 +6612,11 @@
                 <a:spcPts val="0"/>
               </a:spcBef>
               <a:spcAft>
-                <a:spcPts val="900"/>
+                <a:spcPts val="800"/>
               </a:spcAft>
             </a:pPr>
             <a:r>
-              <a:rPr sz="1800" b="1">
+              <a:rPr sz="1700" b="1">
                 <a:solidFill>
                   <a:srgbClr val="C9A227"/>
                 </a:solidFill>
@@ -6365,13 +6625,13 @@
               <a:t>–  </a:t>
             </a:r>
             <a:r>
-              <a:rPr sz="1600">
+              <a:rPr sz="1500">
                 <a:solidFill>
                   <a:srgbClr val="1A1A1A"/>
                 </a:solidFill>
                 <a:latin typeface="Calibri"/>
               </a:rPr>
-              <a:t>„Sutjeska“ (1973) — gde je glumio uz Ričarda Bartona</a:t>
+              <a:t>„Sutjeska“ (1973) — uz Ričarda Bartona</a:t>
             </a:r>
           </a:p>
           <a:p>
@@ -6380,11 +6640,11 @@
                 <a:spcPts val="0"/>
               </a:spcBef>
               <a:spcAft>
-                <a:spcPts val="900"/>
+                <a:spcPts val="800"/>
               </a:spcAft>
             </a:pPr>
             <a:r>
-              <a:rPr sz="1800" b="1">
+              <a:rPr sz="1700" b="1">
                 <a:solidFill>
                   <a:srgbClr val="B01E1E"/>
                 </a:solidFill>
@@ -6393,13 +6653,13 @@
               <a:t>•  </a:t>
             </a:r>
             <a:r>
-              <a:rPr sz="1800">
+              <a:rPr sz="1700">
                 <a:solidFill>
                   <a:srgbClr val="1A1A1A"/>
                 </a:solidFill>
                 <a:latin typeface="Calibri"/>
               </a:rPr>
-              <a:t>Igrao je i u komedijama, dramama i istorijskim filmovima, pokazujući veliki glumački raspon.</a:t>
+              <a:t>Igrao je i u komedijama, dramama i istorijskim filmovima — veliki glumački raspon.</a:t>
             </a:r>
           </a:p>
           <a:p>
@@ -6408,11 +6668,11 @@
                 <a:spcPts val="0"/>
               </a:spcBef>
               <a:spcAft>
-                <a:spcPts val="900"/>
+                <a:spcPts val="800"/>
               </a:spcAft>
             </a:pPr>
             <a:r>
-              <a:rPr sz="1800" b="1">
+              <a:rPr sz="1700" b="1">
                 <a:solidFill>
                   <a:srgbClr val="B01E1E"/>
                 </a:solidFill>
@@ -6421,45 +6681,47 @@
               <a:t>•  </a:t>
             </a:r>
             <a:r>
-              <a:rPr sz="1800">
+              <a:rPr sz="1700">
                 <a:solidFill>
                   <a:srgbClr val="1A1A1A"/>
                 </a:solidFill>
                 <a:latin typeface="Calibri"/>
               </a:rPr>
-              <a:t>Sarađivao je sa najznačajnijim rediteljima jugoslovenske kinematografije.</a:t>
-            </a:r>
-          </a:p>
-          <a:p>
-            <a:pPr>
-              <a:spcBef>
-                <a:spcPts val="0"/>
-              </a:spcBef>
-              <a:spcAft>
-                <a:spcPts val="900"/>
-              </a:spcAft>
-            </a:pPr>
-            <a:r>
-              <a:rPr sz="1800" b="1">
-                <a:solidFill>
-                  <a:srgbClr val="B01E1E"/>
-                </a:solidFill>
-                <a:latin typeface="Calibri"/>
-              </a:rPr>
-              <a:t>•  </a:t>
-            </a:r>
-            <a:r>
-              <a:rPr sz="1800">
-                <a:solidFill>
-                  <a:srgbClr val="1A1A1A"/>
-                </a:solidFill>
-                <a:latin typeface="Calibri"/>
-              </a:rPr>
-              <a:t>Njegova pojava na ekranu postala je zaštitni znak čitave epohe domaćeg filma.</a:t>
-            </a:r>
-          </a:p>
-        </p:txBody>
-      </p:sp>
+              <a:t>Njegova pojava postala je zaštitni znak čitave epohe domaćeg filma.</a:t>
+            </a:r>
+          </a:p>
+        </p:txBody>
+      </p:sp>
+      <p:pic>
+        <p:nvPicPr>
+          <p:cNvPr id="7" name="Picture 6" descr="bata3.jpg"/>
+          <p:cNvPicPr>
+            <a:picLocks noChangeAspect="1"/>
+          </p:cNvPicPr>
+          <p:nvPr/>
+        </p:nvPicPr>
+        <p:blipFill>
+          <a:blip r:embed="rId2"/>
+          <a:srcRect l="16797" r="16797"/>
+          <a:stretch>
+            <a:fillRect/>
+          </a:stretch>
+        </p:blipFill>
+        <p:spPr>
+          <a:xfrm>
+            <a:off x="7680960" y="1737360"/>
+            <a:ext cx="4023360" cy="4023360"/>
+          </a:xfrm>
+          <a:prstGeom prst="rect">
+            <a:avLst/>
+          </a:prstGeom>
+          <a:ln w="38100">
+            <a:solidFill>
+              <a:srgbClr val="C9A227"/>
+            </a:solidFill>
+          </a:ln>
+        </p:spPr>
+      </p:pic>
     </p:spTree>
   </p:cSld>
   <p:clrMapOvr>
@@ -6652,8 +6914,8 @@
         </p:nvSpPr>
         <p:spPr>
           <a:xfrm>
-            <a:off x="914400" y="1554480"/>
-            <a:ext cx="10332720" cy="4937760"/>
+            <a:off x="640080" y="1554480"/>
+            <a:ext cx="6766560" cy="4937760"/>
           </a:xfrm>
           <a:prstGeom prst="rect">
             <a:avLst/>
@@ -6671,11 +6933,11 @@
                 <a:spcPts val="0"/>
               </a:spcBef>
               <a:spcAft>
-                <a:spcPts val="1300"/>
+                <a:spcPts val="1200"/>
               </a:spcAft>
             </a:pPr>
             <a:r>
-              <a:rPr sz="1900" b="1">
+              <a:rPr sz="1800" b="1">
                 <a:solidFill>
                   <a:srgbClr val="B01E1E"/>
                 </a:solidFill>
@@ -6684,7 +6946,7 @@
               <a:t>•  </a:t>
             </a:r>
             <a:r>
-              <a:rPr sz="1900">
+              <a:rPr sz="1800">
                 <a:solidFill>
                   <a:srgbClr val="1A1A1A"/>
                 </a:solidFill>
@@ -6699,11 +6961,11 @@
                 <a:spcPts val="0"/>
               </a:spcBef>
               <a:spcAft>
-                <a:spcPts val="1300"/>
+                <a:spcPts val="1200"/>
               </a:spcAft>
             </a:pPr>
             <a:r>
-              <a:rPr sz="1900" b="1">
+              <a:rPr sz="1800" b="1">
                 <a:solidFill>
                   <a:srgbClr val="B01E1E"/>
                 </a:solidFill>
@@ -6712,7 +6974,7 @@
               <a:t>•  </a:t>
             </a:r>
             <a:r>
-              <a:rPr sz="1900">
+              <a:rPr sz="1800">
                 <a:solidFill>
                   <a:srgbClr val="1A1A1A"/>
                 </a:solidFill>
@@ -6727,11 +6989,11 @@
                 <a:spcPts val="0"/>
               </a:spcBef>
               <a:spcAft>
-                <a:spcPts val="1300"/>
+                <a:spcPts val="1200"/>
               </a:spcAft>
             </a:pPr>
             <a:r>
-              <a:rPr sz="1900" b="1">
+              <a:rPr sz="1800" b="1">
                 <a:solidFill>
                   <a:srgbClr val="C9A227"/>
                 </a:solidFill>
@@ -6740,7 +7002,7 @@
               <a:t>–  </a:t>
             </a:r>
             <a:r>
-              <a:rPr sz="1700">
+              <a:rPr sz="1600">
                 <a:solidFill>
                   <a:srgbClr val="1A1A1A"/>
                 </a:solidFill>
@@ -6755,11 +7017,11 @@
                 <a:spcPts val="0"/>
               </a:spcBef>
               <a:spcAft>
-                <a:spcPts val="1300"/>
+                <a:spcPts val="1200"/>
               </a:spcAft>
             </a:pPr>
             <a:r>
-              <a:rPr sz="1900" b="1">
+              <a:rPr sz="1800" b="1">
                 <a:solidFill>
                   <a:srgbClr val="B01E1E"/>
                 </a:solidFill>
@@ -6768,7 +7030,7 @@
               <a:t>•  </a:t>
             </a:r>
             <a:r>
-              <a:rPr sz="1900">
+              <a:rPr sz="1800">
                 <a:solidFill>
                   <a:srgbClr val="1A1A1A"/>
                 </a:solidFill>
@@ -6783,11 +7045,11 @@
                 <a:spcPts val="0"/>
               </a:spcBef>
               <a:spcAft>
-                <a:spcPts val="1300"/>
+                <a:spcPts val="1200"/>
               </a:spcAft>
             </a:pPr>
             <a:r>
-              <a:rPr sz="1900" b="1">
+              <a:rPr sz="1800" b="1">
                 <a:solidFill>
                   <a:srgbClr val="B01E1E"/>
                 </a:solidFill>
@@ -6796,45 +7058,47 @@
               <a:t>•  </a:t>
             </a:r>
             <a:r>
-              <a:rPr sz="1900">
+              <a:rPr sz="1800">
                 <a:solidFill>
                   <a:srgbClr val="1A1A1A"/>
                 </a:solidFill>
                 <a:latin typeface="Calibri"/>
               </a:rPr>
-              <a:t>Zahvaljujući televiziji, postao je omiljen i prepoznatljiv u svakom domu bivše Jugoslavije.</a:t>
-            </a:r>
-          </a:p>
-          <a:p>
-            <a:pPr>
-              <a:spcBef>
-                <a:spcPts val="0"/>
-              </a:spcBef>
-              <a:spcAft>
-                <a:spcPts val="1300"/>
-              </a:spcAft>
-            </a:pPr>
-            <a:r>
-              <a:rPr sz="1900" b="1">
-                <a:solidFill>
-                  <a:srgbClr val="B01E1E"/>
-                </a:solidFill>
-                <a:latin typeface="Calibri"/>
-              </a:rPr>
-              <a:t>•  </a:t>
-            </a:r>
-            <a:r>
-              <a:rPr sz="1900">
-                <a:solidFill>
-                  <a:srgbClr val="1A1A1A"/>
-                </a:solidFill>
-                <a:latin typeface="Calibri"/>
-              </a:rPr>
-              <a:t>Njegov glas i lik vezuju se za zlatno doba domaće televizijske produkcije.</a:t>
-            </a:r>
-          </a:p>
-        </p:txBody>
-      </p:sp>
+              <a:t>Zahvaljujući televiziji, postao je omiljen u svakom domu bivše Jugoslavije.</a:t>
+            </a:r>
+          </a:p>
+        </p:txBody>
+      </p:sp>
+      <p:pic>
+        <p:nvPicPr>
+          <p:cNvPr id="7" name="Picture 6" descr="bata1.jpg"/>
+          <p:cNvPicPr>
+            <a:picLocks noChangeAspect="1"/>
+          </p:cNvPicPr>
+          <p:nvPr/>
+        </p:nvPicPr>
+        <p:blipFill>
+          <a:blip r:embed="rId2"/>
+          <a:srcRect l="2331" r="2331"/>
+          <a:stretch>
+            <a:fillRect/>
+          </a:stretch>
+        </p:blipFill>
+        <p:spPr>
+          <a:xfrm>
+            <a:off x="7680960" y="1554480"/>
+            <a:ext cx="4023360" cy="4480560"/>
+          </a:xfrm>
+          <a:prstGeom prst="rect">
+            <a:avLst/>
+          </a:prstGeom>
+          <a:ln w="38100">
+            <a:solidFill>
+              <a:srgbClr val="C9A227"/>
+            </a:solidFill>
+          </a:ln>
+        </p:spPr>
+      </p:pic>
     </p:spTree>
   </p:cSld>
   <p:clrMapOvr>
@@ -7027,8 +7291,8 @@
         </p:nvSpPr>
         <p:spPr>
           <a:xfrm>
-            <a:off x="914400" y="1554480"/>
-            <a:ext cx="10332720" cy="4937760"/>
+            <a:off x="640080" y="1554480"/>
+            <a:ext cx="6766560" cy="4937760"/>
           </a:xfrm>
           <a:prstGeom prst="rect">
             <a:avLst/>
@@ -7046,11 +7310,11 @@
                 <a:spcPts val="0"/>
               </a:spcBef>
               <a:spcAft>
-                <a:spcPts val="1300"/>
+                <a:spcPts val="1200"/>
               </a:spcAft>
             </a:pPr>
             <a:r>
-              <a:rPr sz="1900" b="1">
+              <a:rPr sz="1800" b="1">
                 <a:solidFill>
                   <a:srgbClr val="B01E1E"/>
                 </a:solidFill>
@@ -7059,13 +7323,13 @@
               <a:t>•  </a:t>
             </a:r>
             <a:r>
-              <a:rPr sz="1900">
+              <a:rPr sz="1800">
                 <a:solidFill>
                   <a:srgbClr val="1A1A1A"/>
                 </a:solidFill>
                 <a:latin typeface="Calibri"/>
               </a:rPr>
-              <a:t>U drugom delu života Bata Živojinović se aktivno bavio politikom.</a:t>
+              <a:t>U drugom delu života aktivno se bavio politikom.</a:t>
             </a:r>
           </a:p>
           <a:p>
@@ -7074,11 +7338,11 @@
                 <a:spcPts val="0"/>
               </a:spcBef>
               <a:spcAft>
-                <a:spcPts val="1300"/>
+                <a:spcPts val="1200"/>
               </a:spcAft>
             </a:pPr>
             <a:r>
-              <a:rPr sz="1900" b="1">
+              <a:rPr sz="1800" b="1">
                 <a:solidFill>
                   <a:srgbClr val="B01E1E"/>
                 </a:solidFill>
@@ -7087,7 +7351,7 @@
               <a:t>•  </a:t>
             </a:r>
             <a:r>
-              <a:rPr sz="1900">
+              <a:rPr sz="1800">
                 <a:solidFill>
                   <a:srgbClr val="1A1A1A"/>
                 </a:solidFill>
@@ -7102,11 +7366,11 @@
                 <a:spcPts val="0"/>
               </a:spcBef>
               <a:spcAft>
-                <a:spcPts val="1300"/>
+                <a:spcPts val="1200"/>
               </a:spcAft>
             </a:pPr>
             <a:r>
-              <a:rPr sz="1900" b="1">
+              <a:rPr sz="1800" b="1">
                 <a:solidFill>
                   <a:srgbClr val="B01E1E"/>
                 </a:solidFill>
@@ -7115,7 +7379,7 @@
               <a:t>•  </a:t>
             </a:r>
             <a:r>
-              <a:rPr sz="1900">
+              <a:rPr sz="1800">
                 <a:solidFill>
                   <a:srgbClr val="1A1A1A"/>
                 </a:solidFill>
@@ -7130,11 +7394,11 @@
                 <a:spcPts val="0"/>
               </a:spcBef>
               <a:spcAft>
-                <a:spcPts val="1300"/>
+                <a:spcPts val="1200"/>
               </a:spcAft>
             </a:pPr>
             <a:r>
-              <a:rPr sz="1900" b="1">
+              <a:rPr sz="1800" b="1">
                 <a:solidFill>
                   <a:srgbClr val="B01E1E"/>
                 </a:solidFill>
@@ -7143,13 +7407,13 @@
               <a:t>•  </a:t>
             </a:r>
             <a:r>
-              <a:rPr sz="1900">
+              <a:rPr sz="1800">
                 <a:solidFill>
                   <a:srgbClr val="1A1A1A"/>
                 </a:solidFill>
                 <a:latin typeface="Calibri"/>
               </a:rPr>
-              <a:t>Njegov ulazak u politiku bio je propraćen velikom pažnjom javnosti, upravo zbog ogromne popularnosti koju je stekao kao glumac.</a:t>
+              <a:t>Ulazak u politiku propraćen je velikom pažnjom javnosti — zbog ogromne popularnosti koju je stekao kao glumac.</a:t>
             </a:r>
           </a:p>
           <a:p>
@@ -7158,11 +7422,11 @@
                 <a:spcPts val="0"/>
               </a:spcBef>
               <a:spcAft>
-                <a:spcPts val="1300"/>
+                <a:spcPts val="1200"/>
               </a:spcAft>
             </a:pPr>
             <a:r>
-              <a:rPr sz="1900" b="1">
+              <a:rPr sz="1800" b="1">
                 <a:solidFill>
                   <a:srgbClr val="B01E1E"/>
                 </a:solidFill>
@@ -7171,13 +7435,78 @@
               <a:t>•  </a:t>
             </a:r>
             <a:r>
-              <a:rPr sz="1900">
+              <a:rPr sz="1800">
                 <a:solidFill>
                   <a:srgbClr val="1A1A1A"/>
                 </a:solidFill>
                 <a:latin typeface="Calibri"/>
               </a:rPr>
-              <a:t>Iako podeljenih mišljenja o njegovom političkom angažmanu, publika ga je pre svega pamtila kao velikog umetnika.</a:t>
+              <a:t>Publika ga je pre svega pamtila kao velikog umetnika.</a:t>
+            </a:r>
+          </a:p>
+        </p:txBody>
+      </p:sp>
+      <p:pic>
+        <p:nvPicPr>
+          <p:cNvPr id="7" name="Picture 6" descr="skupstina.jpg"/>
+          <p:cNvPicPr>
+            <a:picLocks noChangeAspect="1"/>
+          </p:cNvPicPr>
+          <p:nvPr/>
+        </p:nvPicPr>
+        <p:blipFill>
+          <a:blip r:embed="rId2"/>
+          <a:srcRect l="2849" r="2849"/>
+          <a:stretch>
+            <a:fillRect/>
+          </a:stretch>
+        </p:blipFill>
+        <p:spPr>
+          <a:xfrm>
+            <a:off x="7680960" y="1920240"/>
+            <a:ext cx="4023360" cy="2743200"/>
+          </a:xfrm>
+          <a:prstGeom prst="rect">
+            <a:avLst/>
+          </a:prstGeom>
+          <a:ln w="38100">
+            <a:solidFill>
+              <a:srgbClr val="C9A227"/>
+            </a:solidFill>
+          </a:ln>
+        </p:spPr>
+      </p:pic>
+      <p:sp>
+        <p:nvSpPr>
+          <p:cNvPr id="8" name="TextBox 7"/>
+          <p:cNvSpPr txBox="1"/>
+          <p:nvPr/>
+        </p:nvSpPr>
+        <p:spPr>
+          <a:xfrm>
+            <a:off x="7680960" y="4709160"/>
+            <a:ext cx="4023360" cy="274320"/>
+          </a:xfrm>
+          <a:prstGeom prst="rect">
+            <a:avLst/>
+          </a:prstGeom>
+          <a:noFill/>
+        </p:spPr>
+        <p:txBody>
+          <a:bodyPr wrap="square" anchor="t">
+            <a:spAutoFit/>
+          </a:bodyPr>
+          <a:lstStyle/>
+          <a:p>
+            <a:pPr algn="ctr"/>
+            <a:r>
+              <a:rPr sz="900" b="0" i="1">
+                <a:solidFill>
+                  <a:srgbClr val="3D3D3D"/>
+                </a:solidFill>
+                <a:latin typeface="Calibri"/>
+              </a:rPr>
+              <a:t>U Skupštini Srbije (1990-e)</a:t>
             </a:r>
           </a:p>
         </p:txBody>
@@ -7468,7 +7797,7 @@
                 </a:solidFill>
                 <a:latin typeface="Calibri"/>
               </a:rPr>
-              <a:t>Radnja prati grupu srpskih boraca koji ostaju zarobljeni u tunelu, okruženi neprijateljskim snagama.</a:t>
+              <a:t>Radnja prati grupu srpskih boraca zarobljenih u tunelu, okruženih neprijateljskim snagama.</a:t>
             </a:r>
           </a:p>
           <a:p>
@@ -7496,7 +7825,7 @@
                 </a:solidFill>
                 <a:latin typeface="Calibri"/>
               </a:rPr>
-              <a:t>Film kroz potresne scene prikazuje besmisao rata i raspad nekadašnjeg „bratstva i jedinstva“.</a:t>
+              <a:t>Kroz potresne scene prikazuje besmisao rata i raspad nekadašnjeg „bratstva i jedinstva“.</a:t>
             </a:r>
           </a:p>
           <a:p>
@@ -7524,7 +7853,7 @@
                 </a:solidFill>
                 <a:latin typeface="Calibri"/>
               </a:rPr>
-              <a:t>Smatra se antiratnim filmom — ne slavi rat, već pokazuje njegovu tragediju i ljudsku patnju.</a:t>
+              <a:t>Antiratni film — ne slavi rat, već pokazuje njegovu tragediju i ljudsku patnju.</a:t>
             </a:r>
           </a:p>
         </p:txBody>
@@ -7537,8 +7866,8 @@
         </p:nvSpPr>
         <p:spPr>
           <a:xfrm>
-            <a:off x="7818120" y="7726679"/>
-            <a:ext cx="3931920" cy="4663440"/>
+            <a:off x="7726679" y="1554480"/>
+            <a:ext cx="3977639" cy="4663440"/>
           </a:xfrm>
           <a:prstGeom prst="rect">
             <a:avLst/>
@@ -7581,8 +7910,8 @@
         </p:nvSpPr>
         <p:spPr>
           <a:xfrm>
-            <a:off x="8046720" y="1783080"/>
-            <a:ext cx="3474720" cy="548640"/>
+            <a:off x="7955279" y="1783080"/>
+            <a:ext cx="3520440" cy="548640"/>
           </a:xfrm>
           <a:prstGeom prst="rect">
             <a:avLst/>
@@ -7597,7 +7926,7 @@
           <a:p>
             <a:pPr algn="l"/>
             <a:r>
-              <a:rPr sz="1800" b="1" i="0">
+              <a:rPr sz="1700" b="1" i="0">
                 <a:solidFill>
                   <a:srgbClr val="C9A227"/>
                 </a:solidFill>
@@ -7616,8 +7945,8 @@
         </p:nvSpPr>
         <p:spPr>
           <a:xfrm>
-            <a:off x="8046720" y="2468880"/>
-            <a:ext cx="3520440" cy="3657600"/>
+            <a:off x="7955279" y="2468880"/>
+            <a:ext cx="3566160" cy="3657600"/>
           </a:xfrm>
           <a:prstGeom prst="rect">
             <a:avLst/>
@@ -7654,7 +7983,7 @@
                 </a:solidFill>
                 <a:latin typeface="Calibri"/>
               </a:rPr>
-              <a:t>Tunel u filmu je simbol — bezizlazna situacija i zarobljenost u mržnji rata.</a:t>
+              <a:t>Tunel je simbol — bezizlazna situacija i zarobljenost u mržnji rata.</a:t>
             </a:r>
           </a:p>
           <a:p>
@@ -7907,8 +8236,8 @@
         </p:nvSpPr>
         <p:spPr>
           <a:xfrm>
-            <a:off x="914400" y="1508760"/>
-            <a:ext cx="10332720" cy="5029200"/>
+            <a:off x="640080" y="1508760"/>
+            <a:ext cx="6858000" cy="5029200"/>
           </a:xfrm>
           <a:prstGeom prst="rect">
             <a:avLst/>
@@ -7926,11 +8255,11 @@
                 <a:spcPts val="0"/>
               </a:spcBef>
               <a:spcAft>
-                <a:spcPts val="1000"/>
+                <a:spcPts val="900"/>
               </a:spcAft>
             </a:pPr>
             <a:r>
-              <a:rPr sz="1800" b="1">
+              <a:rPr sz="1700" b="1">
                 <a:solidFill>
                   <a:srgbClr val="B01E1E"/>
                 </a:solidFill>
@@ -7939,7 +8268,7 @@
               <a:t>•  </a:t>
             </a:r>
             <a:r>
-              <a:rPr sz="1800">
+              <a:rPr sz="1700">
                 <a:solidFill>
                   <a:srgbClr val="1A1A1A"/>
                 </a:solidFill>
@@ -7954,11 +8283,11 @@
                 <a:spcPts val="0"/>
               </a:spcBef>
               <a:spcAft>
-                <a:spcPts val="1000"/>
+                <a:spcPts val="900"/>
               </a:spcAft>
             </a:pPr>
             <a:r>
-              <a:rPr sz="1800" b="1">
+              <a:rPr sz="1700" b="1">
                 <a:solidFill>
                   <a:srgbClr val="B01E1E"/>
                 </a:solidFill>
@@ -7967,13 +8296,13 @@
               <a:t>•  </a:t>
             </a:r>
             <a:r>
-              <a:rPr sz="1800">
+              <a:rPr sz="1700">
                 <a:solidFill>
                   <a:srgbClr val="1A1A1A"/>
                 </a:solidFill>
                 <a:latin typeface="Calibri"/>
               </a:rPr>
-              <a:t>Gvozden je nekadašnji radnik i čovek koji je iskreno verovao u ideale „bratstva i jedinstva“ socijalističke Jugoslavije.</a:t>
+              <a:t>Gvozden je nekadašnji radnik koji je iskreno verovao u ideale „bratstva i jedinstva“ socijalističke Jugoslavije.</a:t>
             </a:r>
           </a:p>
           <a:p>
@@ -7982,11 +8311,11 @@
                 <a:spcPts val="0"/>
               </a:spcBef>
               <a:spcAft>
-                <a:spcPts val="1000"/>
+                <a:spcPts val="900"/>
               </a:spcAft>
             </a:pPr>
             <a:r>
-              <a:rPr sz="1800" b="1">
+              <a:rPr sz="1700" b="1">
                 <a:solidFill>
                   <a:srgbClr val="B01E1E"/>
                 </a:solidFill>
@@ -7995,13 +8324,13 @@
               <a:t>•  </a:t>
             </a:r>
             <a:r>
-              <a:rPr sz="1800">
+              <a:rPr sz="1700">
                 <a:solidFill>
                   <a:srgbClr val="1A1A1A"/>
                 </a:solidFill>
                 <a:latin typeface="Calibri"/>
               </a:rPr>
-              <a:t>On predstavlja stariju generaciju — onu koja je gradila zajedničku zemlju i ne može da prihvati da se ona ruši u krvi.</a:t>
+              <a:t>Predstavlja stariju generaciju — onu koja je gradila zajedničku zemlju i ne može da prihvati da se ona ruši u krvi.</a:t>
             </a:r>
           </a:p>
           <a:p>
@@ -8010,11 +8339,11 @@
                 <a:spcPts val="0"/>
               </a:spcBef>
               <a:spcAft>
-                <a:spcPts val="1000"/>
+                <a:spcPts val="900"/>
               </a:spcAft>
             </a:pPr>
             <a:r>
-              <a:rPr sz="1800" b="1">
+              <a:rPr sz="1700" b="1">
                 <a:solidFill>
                   <a:srgbClr val="B01E1E"/>
                 </a:solidFill>
@@ -8023,13 +8352,13 @@
               <a:t>•  </a:t>
             </a:r>
             <a:r>
-              <a:rPr sz="1800">
+              <a:rPr sz="1700">
                 <a:solidFill>
                   <a:srgbClr val="1A1A1A"/>
                 </a:solidFill>
                 <a:latin typeface="Calibri"/>
               </a:rPr>
-              <a:t>Kako rat odmiče, Gvozden sve više gubi nadu i razočaran je u sve oko sebe.</a:t>
+              <a:t>Kako rat odmiče, sve više gubi nadu i razočaran je u sve oko sebe.</a:t>
             </a:r>
           </a:p>
           <a:p>
@@ -8038,11 +8367,11 @@
                 <a:spcPts val="0"/>
               </a:spcBef>
               <a:spcAft>
-                <a:spcPts val="1000"/>
+                <a:spcPts val="900"/>
               </a:spcAft>
             </a:pPr>
             <a:r>
-              <a:rPr sz="1800" b="1">
+              <a:rPr sz="1700" b="1">
                 <a:solidFill>
                   <a:srgbClr val="B01E1E"/>
                 </a:solidFill>
@@ -8051,13 +8380,13 @@
               <a:t>•  </a:t>
             </a:r>
             <a:r>
-              <a:rPr sz="1800">
+              <a:rPr sz="1700">
                 <a:solidFill>
                   <a:srgbClr val="1A1A1A"/>
                 </a:solidFill>
                 <a:latin typeface="Calibri"/>
               </a:rPr>
-              <a:t>Njegov lik je tragičan: simbol sloma jednog sistema vrednosti i jedne epohe.</a:t>
+              <a:t>Tragičan lik — simbol sloma jednog sistema vrednosti i jedne epohe.</a:t>
             </a:r>
           </a:p>
           <a:p>
@@ -8066,11 +8395,11 @@
                 <a:spcPts val="0"/>
               </a:spcBef>
               <a:spcAft>
-                <a:spcPts val="1000"/>
+                <a:spcPts val="900"/>
               </a:spcAft>
             </a:pPr>
             <a:r>
-              <a:rPr sz="1800" b="1">
+              <a:rPr sz="1700" b="1">
                 <a:solidFill>
                   <a:srgbClr val="B01E1E"/>
                 </a:solidFill>
@@ -8079,13 +8408,78 @@
               <a:t>•  </a:t>
             </a:r>
             <a:r>
-              <a:rPr sz="1800">
+              <a:rPr sz="1700">
                 <a:solidFill>
                   <a:srgbClr val="1A1A1A"/>
                 </a:solidFill>
                 <a:latin typeface="Calibri"/>
               </a:rPr>
-              <a:t>U trenutku potpunog očaja, Gvozden donosi sudbonosnu, samoubilačku odluku — što je jedna od najupečatljivijih scena filma.</a:t>
+              <a:t>U trenutku potpunog očaja donosi sudbonosnu, samoubilačku odluku — jedna od najupečatljivijih scena filma.</a:t>
+            </a:r>
+          </a:p>
+        </p:txBody>
+      </p:sp>
+      <p:pic>
+        <p:nvPicPr>
+          <p:cNvPr id="7" name="Picture 6" descr="bata3.jpg"/>
+          <p:cNvPicPr>
+            <a:picLocks noChangeAspect="1"/>
+          </p:cNvPicPr>
+          <p:nvPr/>
+        </p:nvPicPr>
+        <p:blipFill>
+          <a:blip r:embed="rId2"/>
+          <a:srcRect l="16797" r="16797"/>
+          <a:stretch>
+            <a:fillRect/>
+          </a:stretch>
+        </p:blipFill>
+        <p:spPr>
+          <a:xfrm>
+            <a:off x="7680960" y="1737360"/>
+            <a:ext cx="4023360" cy="4023360"/>
+          </a:xfrm>
+          <a:prstGeom prst="rect">
+            <a:avLst/>
+          </a:prstGeom>
+          <a:ln w="38100">
+            <a:solidFill>
+              <a:srgbClr val="C9A227"/>
+            </a:solidFill>
+          </a:ln>
+        </p:spPr>
+      </p:pic>
+      <p:sp>
+        <p:nvSpPr>
+          <p:cNvPr id="8" name="TextBox 7"/>
+          <p:cNvSpPr txBox="1"/>
+          <p:nvPr/>
+        </p:nvSpPr>
+        <p:spPr>
+          <a:xfrm>
+            <a:off x="7680960" y="5806440"/>
+            <a:ext cx="4023360" cy="274320"/>
+          </a:xfrm>
+          <a:prstGeom prst="rect">
+            <a:avLst/>
+          </a:prstGeom>
+          <a:noFill/>
+        </p:spPr>
+        <p:txBody>
+          <a:bodyPr wrap="square" anchor="t">
+            <a:spAutoFit/>
+          </a:bodyPr>
+          <a:lstStyle/>
+          <a:p>
+            <a:pPr algn="ctr"/>
+            <a:r>
+              <a:rPr sz="900" b="0" i="1">
+                <a:solidFill>
+                  <a:srgbClr val="3D3D3D"/>
+                </a:solidFill>
+                <a:latin typeface="Calibri"/>
+              </a:rPr>
+              <a:t>Bata Živojinović — legenda domaćeg glumišta</a:t>
             </a:r>
           </a:p>
         </p:txBody>

</xml_diff>

<commit_message>
Ukloni sekciju izvora i zameni crtice u prezentaciji
Sa zavrsnog slajda uklonjena atribucija izvora; naslov "Hvala na paznji"
recentriran. Sve em/en crte zamenjene obicnom crticom.

Co-Authored-By: Claude Opus 4.8 <noreply@anthropic.com>
Claude-Session: https://claude.ai/code/session_01VHCyUBMH6UXx5KGwtqa7SS
</commit_message>
<xml_diff>
--- a/Bata_Zivojinovic_prezentacija.pptx
+++ b/Bata_Zivojinovic_prezentacija.pptx
@@ -3371,7 +3371,7 @@
                 </a:solidFill>
                 <a:latin typeface="Calibri"/>
               </a:rPr>
-              <a:t>Život i uloge — s posebnim osvrtom na ulogu Gvozdena u filmu „Lepa sela lepo gore“ (1996)</a:t>
+              <a:t>Život i uloge - s posebnim osvrtom na ulogu Gvozdena u filmu „Lepa sela lepo gore“ (1996)</a:t>
             </a:r>
           </a:p>
         </p:txBody>
@@ -3406,7 +3406,7 @@
                 </a:solidFill>
                 <a:latin typeface="Calibri"/>
               </a:rPr>
-              <a:t>1933 — 2016  •  legenda jugoslovenskog i srpskog filma</a:t>
+              <a:t>1933 - 2016  •  legenda jugoslovenskog i srpskog filma</a:t>
             </a:r>
           </a:p>
         </p:txBody>
@@ -4165,7 +4165,7 @@
                 </a:solidFill>
                 <a:latin typeface="Calibri"/>
               </a:rPr>
-              <a:t>Arena u Puli — dom filmskog festivala</a:t>
+              <a:t>Arena u Puli - dom filmskog festivala</a:t>
             </a:r>
           </a:p>
         </p:txBody>
@@ -4553,7 +4553,7 @@
         </p:nvSpPr>
         <p:spPr>
           <a:xfrm>
-            <a:off x="2286000" y="2468880"/>
+            <a:off x="2286000" y="3246120"/>
             <a:ext cx="7589520" cy="50000"/>
           </a:xfrm>
           <a:prstGeom prst="rect">
@@ -4597,7 +4597,7 @@
         </p:nvSpPr>
         <p:spPr>
           <a:xfrm>
-            <a:off x="914400" y="1737360"/>
+            <a:off x="914400" y="2468880"/>
             <a:ext cx="10332720" cy="1097280"/>
           </a:xfrm>
           <a:prstGeom prst="rect">
@@ -4632,7 +4632,7 @@
         </p:nvSpPr>
         <p:spPr>
           <a:xfrm>
-            <a:off x="914400" y="2834640"/>
+            <a:off x="914400" y="3611880"/>
             <a:ext cx="10332720" cy="640080"/>
           </a:xfrm>
           <a:prstGeom prst="rect">
@@ -4655,146 +4655,6 @@
                 <a:latin typeface="Calibri"/>
               </a:rPr>
               <a:t>Pitanja i diskusija dobrodošli</a:t>
-            </a:r>
-          </a:p>
-        </p:txBody>
-      </p:sp>
-      <p:sp>
-        <p:nvSpPr>
-          <p:cNvPr id="5" name="TextBox 4"/>
-          <p:cNvSpPr txBox="1"/>
-          <p:nvPr/>
-        </p:nvSpPr>
-        <p:spPr>
-          <a:xfrm>
-            <a:off x="914400" y="4023360"/>
-            <a:ext cx="10332720" cy="457200"/>
-          </a:xfrm>
-          <a:prstGeom prst="rect">
-            <a:avLst/>
-          </a:prstGeom>
-          <a:noFill/>
-        </p:spPr>
-        <p:txBody>
-          <a:bodyPr wrap="square" anchor="t">
-            <a:spAutoFit/>
-          </a:bodyPr>
-          <a:lstStyle/>
-          <a:p>
-            <a:pPr algn="ctr"/>
-            <a:r>
-              <a:rPr sz="1500" b="1" i="0">
-                <a:solidFill>
-                  <a:srgbClr val="C9A227"/>
-                </a:solidFill>
-                <a:latin typeface="Calibri"/>
-              </a:rPr>
-              <a:t>Izvori teksta:</a:t>
-            </a:r>
-          </a:p>
-        </p:txBody>
-      </p:sp>
-      <p:sp>
-        <p:nvSpPr>
-          <p:cNvPr id="6" name="TextBox 5"/>
-          <p:cNvSpPr txBox="1"/>
-          <p:nvPr/>
-        </p:nvSpPr>
-        <p:spPr>
-          <a:xfrm>
-            <a:off x="1371600" y="4389120"/>
-            <a:ext cx="9418320" cy="457200"/>
-          </a:xfrm>
-          <a:prstGeom prst="rect">
-            <a:avLst/>
-          </a:prstGeom>
-          <a:noFill/>
-        </p:spPr>
-        <p:txBody>
-          <a:bodyPr wrap="square" anchor="t">
-            <a:spAutoFit/>
-          </a:bodyPr>
-          <a:lstStyle/>
-          <a:p>
-            <a:pPr algn="ctr"/>
-            <a:r>
-              <a:rPr sz="1300" b="0" i="0">
-                <a:solidFill>
-                  <a:srgbClr val="F4F1EA"/>
-                </a:solidFill>
-                <a:latin typeface="Calibri"/>
-              </a:rPr>
-              <a:t>Wikipedia i dostupni filmski i biografski materijali</a:t>
-            </a:r>
-          </a:p>
-        </p:txBody>
-      </p:sp>
-      <p:sp>
-        <p:nvSpPr>
-          <p:cNvPr id="7" name="TextBox 6"/>
-          <p:cNvSpPr txBox="1"/>
-          <p:nvPr/>
-        </p:nvSpPr>
-        <p:spPr>
-          <a:xfrm>
-            <a:off x="914400" y="5029200"/>
-            <a:ext cx="10332720" cy="457200"/>
-          </a:xfrm>
-          <a:prstGeom prst="rect">
-            <a:avLst/>
-          </a:prstGeom>
-          <a:noFill/>
-        </p:spPr>
-        <p:txBody>
-          <a:bodyPr wrap="square" anchor="t">
-            <a:spAutoFit/>
-          </a:bodyPr>
-          <a:lstStyle/>
-          <a:p>
-            <a:pPr algn="ctr"/>
-            <a:r>
-              <a:rPr sz="1500" b="1" i="0">
-                <a:solidFill>
-                  <a:srgbClr val="C9A227"/>
-                </a:solidFill>
-                <a:latin typeface="Calibri"/>
-              </a:rPr>
-              <a:t>Fotografije:</a:t>
-            </a:r>
-          </a:p>
-        </p:txBody>
-      </p:sp>
-      <p:sp>
-        <p:nvSpPr>
-          <p:cNvPr id="8" name="TextBox 7"/>
-          <p:cNvSpPr txBox="1"/>
-          <p:nvPr/>
-        </p:nvSpPr>
-        <p:spPr>
-          <a:xfrm>
-            <a:off x="1097280" y="5394960"/>
-            <a:ext cx="9966960" cy="914400"/>
-          </a:xfrm>
-          <a:prstGeom prst="rect">
-            <a:avLst/>
-          </a:prstGeom>
-          <a:noFill/>
-        </p:spPr>
-        <p:txBody>
-          <a:bodyPr wrap="square" anchor="t">
-            <a:spAutoFit/>
-          </a:bodyPr>
-          <a:lstStyle/>
-          <a:p>
-            <a:pPr algn="ctr"/>
-            <a:r>
-              <a:rPr sz="1100" b="0" i="0">
-                <a:solidFill>
-                  <a:srgbClr val="F4F1EA"/>
-                </a:solidFill>
-                <a:latin typeface="Calibri"/>
-              </a:rPr>
-              <a:t>Wikimedia Commons — portreti i fotografija iz Skupštine: Medija centar Beograd / Stevan Kragujević (CC BY-SA 3.0); Kosmaj i Arena u Puli (CC BY-SA); poštanska marka: Pošta Srbije (javno vlasništvo).</a:t>
             </a:r>
           </a:p>
         </p:txBody>
@@ -5169,7 +5029,7 @@
                 </a:solidFill>
                 <a:latin typeface="Calibri"/>
               </a:rPr>
-              <a:t>Film „Lepa sela lepo gore“ — o čemu se radi</a:t>
+              <a:t>Film „Lepa sela lepo gore“ - o čemu se radi</a:t>
             </a:r>
           </a:p>
           <a:p>
@@ -5197,7 +5057,7 @@
                 </a:solidFill>
                 <a:latin typeface="Calibri"/>
               </a:rPr>
-              <a:t>Uloga Gvozdena — analiza lika</a:t>
+              <a:t>Uloga Gvozdena - analiza lika</a:t>
             </a:r>
           </a:p>
           <a:p>
@@ -6538,7 +6398,7 @@
                 </a:solidFill>
                 <a:latin typeface="Calibri"/>
               </a:rPr>
-              <a:t>–  </a:t>
+              <a:t>-  </a:t>
             </a:r>
             <a:r>
               <a:rPr sz="1500">
@@ -6566,7 +6426,7 @@
                 </a:solidFill>
                 <a:latin typeface="Calibri"/>
               </a:rPr>
-              <a:t>–  </a:t>
+              <a:t>-  </a:t>
             </a:r>
             <a:r>
               <a:rPr sz="1500">
@@ -6594,7 +6454,7 @@
                 </a:solidFill>
                 <a:latin typeface="Calibri"/>
               </a:rPr>
-              <a:t>–  </a:t>
+              <a:t>-  </a:t>
             </a:r>
             <a:r>
               <a:rPr sz="1500">
@@ -6622,7 +6482,7 @@
                 </a:solidFill>
                 <a:latin typeface="Calibri"/>
               </a:rPr>
-              <a:t>–  </a:t>
+              <a:t>-  </a:t>
             </a:r>
             <a:r>
               <a:rPr sz="1500">
@@ -6631,7 +6491,7 @@
                 </a:solidFill>
                 <a:latin typeface="Calibri"/>
               </a:rPr>
-              <a:t>„Sutjeska“ (1973) — uz Ričarda Bartona</a:t>
+              <a:t>„Sutjeska“ (1973) - uz Ričarda Bartona</a:t>
             </a:r>
           </a:p>
           <a:p>
@@ -6659,7 +6519,7 @@
                 </a:solidFill>
                 <a:latin typeface="Calibri"/>
               </a:rPr>
-              <a:t>Igrao je i u komedijama, dramama i istorijskim filmovima — veliki glumački raspon.</a:t>
+              <a:t>Igrao je i u komedijama, dramama i istorijskim filmovima - veliki glumački raspon.</a:t>
             </a:r>
           </a:p>
           <a:p>
@@ -6999,7 +6859,7 @@
                 </a:solidFill>
                 <a:latin typeface="Calibri"/>
               </a:rPr>
-              <a:t>–  </a:t>
+              <a:t>-  </a:t>
             </a:r>
             <a:r>
               <a:rPr sz="1600">
@@ -7008,7 +6868,7 @@
                 </a:solidFill>
                 <a:latin typeface="Calibri"/>
               </a:rPr>
-              <a:t>„Otpisani“ i „Povratak otpisanih“ — priče o beogradskim ilegalcima u Drugom svetskom ratu.</a:t>
+              <a:t>„Otpisani“ i „Povratak otpisanih“ - priče o beogradskim ilegalcima u Drugom svetskom ratu.</a:t>
             </a:r>
           </a:p>
           <a:p>
@@ -7413,7 +7273,7 @@
                 </a:solidFill>
                 <a:latin typeface="Calibri"/>
               </a:rPr>
-              <a:t>Ulazak u politiku propraćen je velikom pažnjom javnosti — zbog ogromne popularnosti koju je stekao kao glumac.</a:t>
+              <a:t>Ulazak u politiku propraćen je velikom pažnjom javnosti - zbog ogromne popularnosti koju je stekao kao glumac.</a:t>
             </a:r>
           </a:p>
           <a:p>
@@ -7769,7 +7629,7 @@
                 </a:solidFill>
                 <a:latin typeface="Calibri"/>
               </a:rPr>
-              <a:t>Jedan od najznačajnijih i najpotresnijih srpskih filmova o ratu u Bosni (1992–1995).</a:t>
+              <a:t>Jedan od najznačajnijih i najpotresnijih srpskih filmova o ratu u Bosni (1992-1995).</a:t>
             </a:r>
           </a:p>
           <a:p>
@@ -7853,7 +7713,7 @@
                 </a:solidFill>
                 <a:latin typeface="Calibri"/>
               </a:rPr>
-              <a:t>Antiratni film — ne slavi rat, već pokazuje njegovu tragediju i ljudsku patnju.</a:t>
+              <a:t>Antiratni film - ne slavi rat, već pokazuje njegovu tragediju i ljudsku patnju.</a:t>
             </a:r>
           </a:p>
         </p:txBody>
@@ -7983,7 +7843,7 @@
                 </a:solidFill>
                 <a:latin typeface="Calibri"/>
               </a:rPr>
-              <a:t>Tunel je simbol — bezizlazna situacija i zarobljenost u mržnji rata.</a:t>
+              <a:t>Tunel je simbol - bezizlazna situacija i zarobljenost u mržnji rata.</a:t>
             </a:r>
           </a:p>
           <a:p>
@@ -8223,7 +8083,7 @@
                 </a:solidFill>
                 <a:latin typeface="Calibri"/>
               </a:rPr>
-              <a:t>Uloga Gvozdena — analiza lika</a:t>
+              <a:t>Uloga Gvozdena - analiza lika</a:t>
             </a:r>
           </a:p>
         </p:txBody>
@@ -8274,7 +8134,7 @@
                 </a:solidFill>
                 <a:latin typeface="Calibri"/>
               </a:rPr>
-              <a:t>Bata Živojinović tumači Gvozdena — starijeg, iskusnog borca među zarobljenim vojnicima.</a:t>
+              <a:t>Bata Živojinović tumači Gvozdena - starijeg, iskusnog borca među zarobljenim vojnicima.</a:t>
             </a:r>
           </a:p>
           <a:p>
@@ -8330,7 +8190,7 @@
                 </a:solidFill>
                 <a:latin typeface="Calibri"/>
               </a:rPr>
-              <a:t>Predstavlja stariju generaciju — onu koja je gradila zajedničku zemlju i ne može da prihvati da se ona ruši u krvi.</a:t>
+              <a:t>Predstavlja stariju generaciju - onu koja je gradila zajedničku zemlju i ne može da prihvati da se ona ruši u krvi.</a:t>
             </a:r>
           </a:p>
           <a:p>
@@ -8386,7 +8246,7 @@
                 </a:solidFill>
                 <a:latin typeface="Calibri"/>
               </a:rPr>
-              <a:t>Tragičan lik — simbol sloma jednog sistema vrednosti i jedne epohe.</a:t>
+              <a:t>Tragičan lik - simbol sloma jednog sistema vrednosti i jedne epohe.</a:t>
             </a:r>
           </a:p>
           <a:p>
@@ -8414,7 +8274,7 @@
                 </a:solidFill>
                 <a:latin typeface="Calibri"/>
               </a:rPr>
-              <a:t>U trenutku potpunog očaja donosi sudbonosnu, samoubilačku odluku — jedna od najupečatljivijih scena filma.</a:t>
+              <a:t>U trenutku potpunog očaja donosi sudbonosnu, samoubilačku odluku - jedna od najupečatljivijih scena filma.</a:t>
             </a:r>
           </a:p>
         </p:txBody>
@@ -8479,7 +8339,7 @@
                 </a:solidFill>
                 <a:latin typeface="Calibri"/>
               </a:rPr>
-              <a:t>Bata Živojinović — legenda domaćeg glumišta</a:t>
+              <a:t>Bata Živojinović - legenda domaćeg glumišta</a:t>
             </a:r>
           </a:p>
         </p:txBody>

</xml_diff>

<commit_message>
Dodaj ime autorke i bold isticanje kljucnih pojmova
Naslovna oznaka zamenjena imenom autorke (Andjela Stefanov). Funkcija
bullets nadogradjena da podrzava inline bold preko **...**; izboldovani
kljucni pojmovi (imena, filmovi, datumi, koncepti) kroz celu prezentaciju.

Co-Authored-By: Claude Opus 4.8 <noreply@anthropic.com>
Claude-Session: https://claude.ai/code/session_01VHCyUBMH6UXx5KGwtqa7SS
</commit_message>
<xml_diff>
--- a/Bata_Zivojinovic_prezentacija.pptx
+++ b/Bata_Zivojinovic_prezentacija.pptx
@@ -3250,13 +3250,13 @@
           <a:p>
             <a:pPr algn="l"/>
             <a:r>
-              <a:rPr sz="1500" b="1" i="0">
+              <a:rPr sz="1700" b="1" i="0">
                 <a:solidFill>
                   <a:srgbClr val="C9A227"/>
                 </a:solidFill>
                 <a:latin typeface="Calibri"/>
               </a:rPr>
-              <a:t>MATURSKA / SEMINARSKA PREZENTACIJA</a:t>
+              <a:t>Anđela Stefanov</a:t>
             </a:r>
           </a:p>
         </p:txBody>
@@ -3635,13 +3635,31 @@
               <a:t>•  </a:t>
             </a:r>
             <a:r>
-              <a:rPr sz="1900">
-                <a:solidFill>
-                  <a:srgbClr val="1A1A1A"/>
-                </a:solidFill>
-                <a:latin typeface="Calibri"/>
-              </a:rPr>
-              <a:t>Uloga Gvozdena je posebno značajna jer Batu Živojinovića vidimo u potpuno novom svetlu.</a:t>
+              <a:rPr sz="1900" b="0">
+                <a:solidFill>
+                  <a:srgbClr val="1A1A1A"/>
+                </a:solidFill>
+                <a:latin typeface="Calibri"/>
+              </a:rPr>
+              <a:t>Uloga Gvozdena je posebno značajna jer Batu Živojinovića vidimo u </a:t>
+            </a:r>
+            <a:r>
+              <a:rPr sz="1900" b="1">
+                <a:solidFill>
+                  <a:srgbClr val="1A1A1A"/>
+                </a:solidFill>
+                <a:latin typeface="Calibri"/>
+              </a:rPr>
+              <a:t>potpuno novom svetlu</a:t>
+            </a:r>
+            <a:r>
+              <a:rPr sz="1900" b="0">
+                <a:solidFill>
+                  <a:srgbClr val="1A1A1A"/>
+                </a:solidFill>
+                <a:latin typeface="Calibri"/>
+              </a:rPr>
+              <a:t>.</a:t>
             </a:r>
           </a:p>
           <a:p>
@@ -3663,13 +3681,31 @@
               <a:t>•  </a:t>
             </a:r>
             <a:r>
-              <a:rPr sz="1900">
-                <a:solidFill>
-                  <a:srgbClr val="1A1A1A"/>
-                </a:solidFill>
-                <a:latin typeface="Calibri"/>
-              </a:rPr>
-              <a:t>Glumac koji je decenijama bio simbol partizanskih, pobedničkih junaka, sada igra slomljenog, razočaranog čoveka.</a:t>
+              <a:rPr sz="1900" b="0">
+                <a:solidFill>
+                  <a:srgbClr val="1A1A1A"/>
+                </a:solidFill>
+                <a:latin typeface="Calibri"/>
+              </a:rPr>
+              <a:t>Glumac koji je decenijama bio simbol </a:t>
+            </a:r>
+            <a:r>
+              <a:rPr sz="1900" b="1">
+                <a:solidFill>
+                  <a:srgbClr val="1A1A1A"/>
+                </a:solidFill>
+                <a:latin typeface="Calibri"/>
+              </a:rPr>
+              <a:t>partizanskih, pobedničkih junaka</a:t>
+            </a:r>
+            <a:r>
+              <a:rPr sz="1900" b="0">
+                <a:solidFill>
+                  <a:srgbClr val="1A1A1A"/>
+                </a:solidFill>
+                <a:latin typeface="Calibri"/>
+              </a:rPr>
+              <a:t>, sada igra slomljenog, razočaranog čoveka.</a:t>
             </a:r>
           </a:p>
           <a:p>
@@ -3691,13 +3727,31 @@
               <a:t>•  </a:t>
             </a:r>
             <a:r>
-              <a:rPr sz="1900">
-                <a:solidFill>
-                  <a:srgbClr val="1A1A1A"/>
-                </a:solidFill>
-                <a:latin typeface="Calibri"/>
-              </a:rPr>
-              <a:t>Stvara se snažan kontrast: nekadašnji „heroj bratstva i jedinstva“ suočava se sa raspadom svega u šta je verovao.</a:t>
+              <a:rPr sz="1900" b="0">
+                <a:solidFill>
+                  <a:srgbClr val="1A1A1A"/>
+                </a:solidFill>
+                <a:latin typeface="Calibri"/>
+              </a:rPr>
+              <a:t>Stvara se </a:t>
+            </a:r>
+            <a:r>
+              <a:rPr sz="1900" b="1">
+                <a:solidFill>
+                  <a:srgbClr val="1A1A1A"/>
+                </a:solidFill>
+                <a:latin typeface="Calibri"/>
+              </a:rPr>
+              <a:t>snažan kontrast</a:t>
+            </a:r>
+            <a:r>
+              <a:rPr sz="1900" b="0">
+                <a:solidFill>
+                  <a:srgbClr val="1A1A1A"/>
+                </a:solidFill>
+                <a:latin typeface="Calibri"/>
+              </a:rPr>
+              <a:t>: nekadašnji „heroj bratstva i jedinstva“ suočava se sa raspadom svega u šta je verovao.</a:t>
             </a:r>
           </a:p>
           <a:p>
@@ -3719,13 +3773,31 @@
               <a:t>•  </a:t>
             </a:r>
             <a:r>
-              <a:rPr sz="1900">
-                <a:solidFill>
-                  <a:srgbClr val="1A1A1A"/>
-                </a:solidFill>
-                <a:latin typeface="Calibri"/>
-              </a:rPr>
-              <a:t>Poruka filma kroz Gvozdena: rat uništava ne samo živote, već i ideale i ljudskost.</a:t>
+              <a:rPr sz="1900" b="0">
+                <a:solidFill>
+                  <a:srgbClr val="1A1A1A"/>
+                </a:solidFill>
+                <a:latin typeface="Calibri"/>
+              </a:rPr>
+              <a:t>Poruka filma kroz Gvozdena: </a:t>
+            </a:r>
+            <a:r>
+              <a:rPr sz="1900" b="1">
+                <a:solidFill>
+                  <a:srgbClr val="1A1A1A"/>
+                </a:solidFill>
+                <a:latin typeface="Calibri"/>
+              </a:rPr>
+              <a:t>rat uništava ne samo živote, već i ideale i ljudskost</a:t>
+            </a:r>
+            <a:r>
+              <a:rPr sz="1900" b="0">
+                <a:solidFill>
+                  <a:srgbClr val="1A1A1A"/>
+                </a:solidFill>
+                <a:latin typeface="Calibri"/>
+              </a:rPr>
+              <a:t>.</a:t>
             </a:r>
           </a:p>
           <a:p>
@@ -3747,7 +3819,7 @@
               <a:t>•  </a:t>
             </a:r>
             <a:r>
-              <a:rPr sz="1900">
+              <a:rPr sz="1900" b="0">
                 <a:solidFill>
                   <a:srgbClr val="1A1A1A"/>
                 </a:solidFill>
@@ -3982,13 +4054,31 @@
               <a:t>•  </a:t>
             </a:r>
             <a:r>
-              <a:rPr sz="1800">
-                <a:solidFill>
-                  <a:srgbClr val="1A1A1A"/>
-                </a:solidFill>
-                <a:latin typeface="Calibri"/>
-              </a:rPr>
-              <a:t>Osvojio je brojne nagrade, među kojima i prestižne Zlatne arene na festivalu u Puli.</a:t>
+              <a:rPr sz="1800" b="0">
+                <a:solidFill>
+                  <a:srgbClr val="1A1A1A"/>
+                </a:solidFill>
+                <a:latin typeface="Calibri"/>
+              </a:rPr>
+              <a:t>Osvojio je brojne nagrade, među kojima i prestižne </a:t>
+            </a:r>
+            <a:r>
+              <a:rPr sz="1800" b="1">
+                <a:solidFill>
+                  <a:srgbClr val="1A1A1A"/>
+                </a:solidFill>
+                <a:latin typeface="Calibri"/>
+              </a:rPr>
+              <a:t>Zlatne arene</a:t>
+            </a:r>
+            <a:r>
+              <a:rPr sz="1800" b="0">
+                <a:solidFill>
+                  <a:srgbClr val="1A1A1A"/>
+                </a:solidFill>
+                <a:latin typeface="Calibri"/>
+              </a:rPr>
+              <a:t> na festivalu u Puli.</a:t>
             </a:r>
           </a:p>
           <a:p>
@@ -4010,13 +4100,31 @@
               <a:t>•  </a:t>
             </a:r>
             <a:r>
-              <a:rPr sz="1800">
-                <a:solidFill>
-                  <a:srgbClr val="1A1A1A"/>
-                </a:solidFill>
-                <a:latin typeface="Calibri"/>
-              </a:rPr>
-              <a:t>Dobitnik je priznanja za životno delo i mnogih drugih umetničkih nagrada.</a:t>
+              <a:rPr sz="1800" b="0">
+                <a:solidFill>
+                  <a:srgbClr val="1A1A1A"/>
+                </a:solidFill>
+                <a:latin typeface="Calibri"/>
+              </a:rPr>
+              <a:t>Dobitnik je priznanja za </a:t>
+            </a:r>
+            <a:r>
+              <a:rPr sz="1800" b="1">
+                <a:solidFill>
+                  <a:srgbClr val="1A1A1A"/>
+                </a:solidFill>
+                <a:latin typeface="Calibri"/>
+              </a:rPr>
+              <a:t>životno delo</a:t>
+            </a:r>
+            <a:r>
+              <a:rPr sz="1800" b="0">
+                <a:solidFill>
+                  <a:srgbClr val="1A1A1A"/>
+                </a:solidFill>
+                <a:latin typeface="Calibri"/>
+              </a:rPr>
+              <a:t> i mnogih drugih umetničkih nagrada.</a:t>
             </a:r>
           </a:p>
           <a:p>
@@ -4038,13 +4146,31 @@
               <a:t>•  </a:t>
             </a:r>
             <a:r>
-              <a:rPr sz="1800">
-                <a:solidFill>
-                  <a:srgbClr val="1A1A1A"/>
-                </a:solidFill>
-                <a:latin typeface="Calibri"/>
-              </a:rPr>
-              <a:t>Smatra se jednim od najvećih glumaca ovih prostora svih vremena.</a:t>
+              <a:rPr sz="1800" b="0">
+                <a:solidFill>
+                  <a:srgbClr val="1A1A1A"/>
+                </a:solidFill>
+                <a:latin typeface="Calibri"/>
+              </a:rPr>
+              <a:t>Smatra se </a:t>
+            </a:r>
+            <a:r>
+              <a:rPr sz="1800" b="1">
+                <a:solidFill>
+                  <a:srgbClr val="1A1A1A"/>
+                </a:solidFill>
+                <a:latin typeface="Calibri"/>
+              </a:rPr>
+              <a:t>jednim od najvećih glumaca</a:t>
+            </a:r>
+            <a:r>
+              <a:rPr sz="1800" b="0">
+                <a:solidFill>
+                  <a:srgbClr val="1A1A1A"/>
+                </a:solidFill>
+                <a:latin typeface="Calibri"/>
+              </a:rPr>
+              <a:t> ovih prostora svih vremena.</a:t>
             </a:r>
           </a:p>
           <a:p>
@@ -4066,13 +4192,31 @@
               <a:t>•  </a:t>
             </a:r>
             <a:r>
-              <a:rPr sz="1800">
-                <a:solidFill>
-                  <a:srgbClr val="1A1A1A"/>
-                </a:solidFill>
-                <a:latin typeface="Calibri"/>
-              </a:rPr>
-              <a:t>Preminuo je 22. maja 2016. u Beogradu, u 83. godini.</a:t>
+              <a:rPr sz="1800" b="0">
+                <a:solidFill>
+                  <a:srgbClr val="1A1A1A"/>
+                </a:solidFill>
+                <a:latin typeface="Calibri"/>
+              </a:rPr>
+              <a:t>Preminuo je </a:t>
+            </a:r>
+            <a:r>
+              <a:rPr sz="1800" b="1">
+                <a:solidFill>
+                  <a:srgbClr val="1A1A1A"/>
+                </a:solidFill>
+                <a:latin typeface="Calibri"/>
+              </a:rPr>
+              <a:t>22. maja 2016.</a:t>
+            </a:r>
+            <a:r>
+              <a:rPr sz="1800" b="0">
+                <a:solidFill>
+                  <a:srgbClr val="1A1A1A"/>
+                </a:solidFill>
+                <a:latin typeface="Calibri"/>
+              </a:rPr>
+              <a:t> u Beogradu, u 83. godini.</a:t>
             </a:r>
           </a:p>
           <a:p>
@@ -4094,7 +4238,7 @@
               <a:t>•  </a:t>
             </a:r>
             <a:r>
-              <a:rPr sz="1800">
+              <a:rPr sz="1800" b="0">
                 <a:solidFill>
                   <a:srgbClr val="1A1A1A"/>
                 </a:solidFill>
@@ -4424,13 +4568,31 @@
               <a:t>•  </a:t>
             </a:r>
             <a:r>
-              <a:rPr sz="2000">
+              <a:rPr sz="2000" b="0">
                 <a:solidFill>
                   <a:srgbClr val="F4F1EA"/>
                 </a:solidFill>
                 <a:latin typeface="Calibri"/>
               </a:rPr>
-              <a:t>Bata Živojinović je svojim talentom i radom obeležio čitavu epohu domaćeg filma.</a:t>
+              <a:t>Bata Živojinović je svojim talentom i radom </a:t>
+            </a:r>
+            <a:r>
+              <a:rPr sz="2000" b="1">
+                <a:solidFill>
+                  <a:srgbClr val="F4F1EA"/>
+                </a:solidFill>
+                <a:latin typeface="Calibri"/>
+              </a:rPr>
+              <a:t>obeležio čitavu epohu</a:t>
+            </a:r>
+            <a:r>
+              <a:rPr sz="2000" b="0">
+                <a:solidFill>
+                  <a:srgbClr val="F4F1EA"/>
+                </a:solidFill>
+                <a:latin typeface="Calibri"/>
+              </a:rPr>
+              <a:t> domaćeg filma.</a:t>
             </a:r>
           </a:p>
           <a:p>
@@ -4452,13 +4614,31 @@
               <a:t>•  </a:t>
             </a:r>
             <a:r>
-              <a:rPr sz="2000">
+              <a:rPr sz="2000" b="0">
                 <a:solidFill>
                   <a:srgbClr val="F4F1EA"/>
                 </a:solidFill>
                 <a:latin typeface="Calibri"/>
               </a:rPr>
-              <a:t>Od hrabrih partizanskih junaka do tragičnog Gvozdena, pokazao je izuzetan glumački raspon.</a:t>
+              <a:t>Od hrabrih partizanskih junaka do tragičnog Gvozdena, pokazao je </a:t>
+            </a:r>
+            <a:r>
+              <a:rPr sz="2000" b="1">
+                <a:solidFill>
+                  <a:srgbClr val="F4F1EA"/>
+                </a:solidFill>
+                <a:latin typeface="Calibri"/>
+              </a:rPr>
+              <a:t>izuzetan glumački raspon</a:t>
+            </a:r>
+            <a:r>
+              <a:rPr sz="2000" b="0">
+                <a:solidFill>
+                  <a:srgbClr val="F4F1EA"/>
+                </a:solidFill>
+                <a:latin typeface="Calibri"/>
+              </a:rPr>
+              <a:t>.</a:t>
             </a:r>
           </a:p>
           <a:p>
@@ -4480,13 +4660,31 @@
               <a:t>•  </a:t>
             </a:r>
             <a:r>
-              <a:rPr sz="2000">
+              <a:rPr sz="2000" b="0">
                 <a:solidFill>
                   <a:srgbClr val="F4F1EA"/>
                 </a:solidFill>
                 <a:latin typeface="Calibri"/>
               </a:rPr>
-              <a:t>Uloga u filmu „Lepa sela lepo gore“ potvrdila je njegovu veličinu i u ozbiljnim, antiratnim ostvarenjima.</a:t>
+              <a:t>Uloga u filmu „Lepa sela lepo gore“ potvrdila je njegovu veličinu i u </a:t>
+            </a:r>
+            <a:r>
+              <a:rPr sz="2000" b="1">
+                <a:solidFill>
+                  <a:srgbClr val="F4F1EA"/>
+                </a:solidFill>
+                <a:latin typeface="Calibri"/>
+              </a:rPr>
+              <a:t>ozbiljnim, antiratnim ostvarenjima</a:t>
+            </a:r>
+            <a:r>
+              <a:rPr sz="2000" b="0">
+                <a:solidFill>
+                  <a:srgbClr val="F4F1EA"/>
+                </a:solidFill>
+                <a:latin typeface="Calibri"/>
+              </a:rPr>
+              <a:t>.</a:t>
             </a:r>
           </a:p>
           <a:p>
@@ -4508,13 +4706,49 @@
               <a:t>•  </a:t>
             </a:r>
             <a:r>
-              <a:rPr sz="2000">
+              <a:rPr sz="2000" b="0">
                 <a:solidFill>
                   <a:srgbClr val="F4F1EA"/>
                 </a:solidFill>
                 <a:latin typeface="Calibri"/>
               </a:rPr>
-              <a:t>Ostaje upamćen kao legenda i jedan od najvoljenijih glumaca naših prostora.</a:t>
+              <a:t>Ostaje upamćen kao </a:t>
+            </a:r>
+            <a:r>
+              <a:rPr sz="2000" b="1">
+                <a:solidFill>
+                  <a:srgbClr val="F4F1EA"/>
+                </a:solidFill>
+                <a:latin typeface="Calibri"/>
+              </a:rPr>
+              <a:t>legenda</a:t>
+            </a:r>
+            <a:r>
+              <a:rPr sz="2000" b="0">
+                <a:solidFill>
+                  <a:srgbClr val="F4F1EA"/>
+                </a:solidFill>
+                <a:latin typeface="Calibri"/>
+              </a:rPr>
+              <a:t> i jedan od </a:t>
+            </a:r>
+            <a:r>
+              <a:rPr sz="2000" b="1">
+                <a:solidFill>
+                  <a:srgbClr val="F4F1EA"/>
+                </a:solidFill>
+                <a:latin typeface="Calibri"/>
+              </a:rPr>
+              <a:t>najvoljenijih glumaca</a:t>
+            </a:r>
+            <a:r>
+              <a:rPr sz="2000" b="0">
+                <a:solidFill>
+                  <a:srgbClr val="F4F1EA"/>
+                </a:solidFill>
+                <a:latin typeface="Calibri"/>
+              </a:rPr>
+              <a:t> naših prostora.</a:t>
             </a:r>
           </a:p>
         </p:txBody>
@@ -4883,7 +5117,7 @@
               <a:t>•  </a:t>
             </a:r>
             <a:r>
-              <a:rPr sz="2000">
+              <a:rPr sz="2000" b="0">
                 <a:solidFill>
                   <a:srgbClr val="1A1A1A"/>
                 </a:solidFill>
@@ -4911,7 +5145,7 @@
               <a:t>•  </a:t>
             </a:r>
             <a:r>
-              <a:rPr sz="2000">
+              <a:rPr sz="2000" b="0">
                 <a:solidFill>
                   <a:srgbClr val="1A1A1A"/>
                 </a:solidFill>
@@ -4939,7 +5173,7 @@
               <a:t>•  </a:t>
             </a:r>
             <a:r>
-              <a:rPr sz="2000">
+              <a:rPr sz="2000" b="0">
                 <a:solidFill>
                   <a:srgbClr val="1A1A1A"/>
                 </a:solidFill>
@@ -4967,7 +5201,7 @@
               <a:t>•  </a:t>
             </a:r>
             <a:r>
-              <a:rPr sz="2000">
+              <a:rPr sz="2000" b="0">
                 <a:solidFill>
                   <a:srgbClr val="1A1A1A"/>
                 </a:solidFill>
@@ -4995,7 +5229,7 @@
               <a:t>•  </a:t>
             </a:r>
             <a:r>
-              <a:rPr sz="2000">
+              <a:rPr sz="2000" b="0">
                 <a:solidFill>
                   <a:srgbClr val="1A1A1A"/>
                 </a:solidFill>
@@ -5023,7 +5257,7 @@
               <a:t>•  </a:t>
             </a:r>
             <a:r>
-              <a:rPr sz="2000">
+              <a:rPr sz="2000" b="0">
                 <a:solidFill>
                   <a:srgbClr val="1A1A1A"/>
                 </a:solidFill>
@@ -5051,7 +5285,7 @@
               <a:t>•  </a:t>
             </a:r>
             <a:r>
-              <a:rPr sz="2000">
+              <a:rPr sz="2000" b="0">
                 <a:solidFill>
                   <a:srgbClr val="1A1A1A"/>
                 </a:solidFill>
@@ -5079,7 +5313,7 @@
               <a:t>•  </a:t>
             </a:r>
             <a:r>
-              <a:rPr sz="2000">
+              <a:rPr sz="2000" b="0">
                 <a:solidFill>
                   <a:srgbClr val="1A1A1A"/>
                 </a:solidFill>
@@ -5107,7 +5341,7 @@
               <a:t>•  </a:t>
             </a:r>
             <a:r>
-              <a:rPr sz="2000">
+              <a:rPr sz="2000" b="0">
                 <a:solidFill>
                   <a:srgbClr val="1A1A1A"/>
                 </a:solidFill>
@@ -5135,7 +5369,7 @@
               <a:t>•  </a:t>
             </a:r>
             <a:r>
-              <a:rPr sz="2000">
+              <a:rPr sz="2000" b="0">
                 <a:solidFill>
                   <a:srgbClr val="1A1A1A"/>
                 </a:solidFill>
@@ -5370,13 +5604,31 @@
               <a:t>•  </a:t>
             </a:r>
             <a:r>
-              <a:rPr sz="1800">
-                <a:solidFill>
-                  <a:srgbClr val="1A1A1A"/>
-                </a:solidFill>
-                <a:latin typeface="Calibri"/>
-              </a:rPr>
-              <a:t>Jedan od najpoznatijih i najplodnijih glumaca u istoriji jugoslovenskog i srpskog filma.</a:t>
+              <a:rPr sz="1800" b="0">
+                <a:solidFill>
+                  <a:srgbClr val="1A1A1A"/>
+                </a:solidFill>
+                <a:latin typeface="Calibri"/>
+              </a:rPr>
+              <a:t>Jedan od </a:t>
+            </a:r>
+            <a:r>
+              <a:rPr sz="1800" b="1">
+                <a:solidFill>
+                  <a:srgbClr val="1A1A1A"/>
+                </a:solidFill>
+                <a:latin typeface="Calibri"/>
+              </a:rPr>
+              <a:t>najpoznatijih i najplodnijih glumaca</a:t>
+            </a:r>
+            <a:r>
+              <a:rPr sz="1800" b="0">
+                <a:solidFill>
+                  <a:srgbClr val="1A1A1A"/>
+                </a:solidFill>
+                <a:latin typeface="Calibri"/>
+              </a:rPr>
+              <a:t> u istoriji jugoslovenskog i srpskog filma.</a:t>
             </a:r>
           </a:p>
           <a:p>
@@ -5398,13 +5650,31 @@
               <a:t>•  </a:t>
             </a:r>
             <a:r>
-              <a:rPr sz="1800">
-                <a:solidFill>
-                  <a:srgbClr val="1A1A1A"/>
-                </a:solidFill>
-                <a:latin typeface="Calibri"/>
-              </a:rPr>
-              <a:t>Tokom karijere igrao je u više od 300 filmova i televizijskih ostvarenja.</a:t>
+              <a:rPr sz="1800" b="0">
+                <a:solidFill>
+                  <a:srgbClr val="1A1A1A"/>
+                </a:solidFill>
+                <a:latin typeface="Calibri"/>
+              </a:rPr>
+              <a:t>Tokom karijere igrao je u </a:t>
+            </a:r>
+            <a:r>
+              <a:rPr sz="1800" b="1">
+                <a:solidFill>
+                  <a:srgbClr val="1A1A1A"/>
+                </a:solidFill>
+                <a:latin typeface="Calibri"/>
+              </a:rPr>
+              <a:t>više od 300 filmova</a:t>
+            </a:r>
+            <a:r>
+              <a:rPr sz="1800" b="0">
+                <a:solidFill>
+                  <a:srgbClr val="1A1A1A"/>
+                </a:solidFill>
+                <a:latin typeface="Calibri"/>
+              </a:rPr>
+              <a:t> i televizijskih ostvarenja.</a:t>
             </a:r>
           </a:p>
           <a:p>
@@ -5426,13 +5696,31 @@
               <a:t>•  </a:t>
             </a:r>
             <a:r>
-              <a:rPr sz="1800">
-                <a:solidFill>
-                  <a:srgbClr val="1A1A1A"/>
-                </a:solidFill>
-                <a:latin typeface="Calibri"/>
-              </a:rPr>
-              <a:t>Postao je prepoznatljiv kao simbol „partizanskih“ ratnih filmova i otelotvorenje narodnog junaka.</a:t>
+              <a:rPr sz="1800" b="0">
+                <a:solidFill>
+                  <a:srgbClr val="1A1A1A"/>
+                </a:solidFill>
+                <a:latin typeface="Calibri"/>
+              </a:rPr>
+              <a:t>Postao je prepoznatljiv kao simbol </a:t>
+            </a:r>
+            <a:r>
+              <a:rPr sz="1800" b="1">
+                <a:solidFill>
+                  <a:srgbClr val="1A1A1A"/>
+                </a:solidFill>
+                <a:latin typeface="Calibri"/>
+              </a:rPr>
+              <a:t>„partizanskih“ ratnih filmova</a:t>
+            </a:r>
+            <a:r>
+              <a:rPr sz="1800" b="0">
+                <a:solidFill>
+                  <a:srgbClr val="1A1A1A"/>
+                </a:solidFill>
+                <a:latin typeface="Calibri"/>
+              </a:rPr>
+              <a:t> i otelotvorenje narodnog junaka.</a:t>
             </a:r>
           </a:p>
           <a:p>
@@ -5454,13 +5742,31 @@
               <a:t>•  </a:t>
             </a:r>
             <a:r>
-              <a:rPr sz="1800">
-                <a:solidFill>
-                  <a:srgbClr val="1A1A1A"/>
-                </a:solidFill>
-                <a:latin typeface="Calibri"/>
-              </a:rPr>
-              <a:t>Voljen kod publike zbog topline, autentičnosti i snažne ekranske pojave.</a:t>
+              <a:rPr sz="1800" b="0">
+                <a:solidFill>
+                  <a:srgbClr val="1A1A1A"/>
+                </a:solidFill>
+                <a:latin typeface="Calibri"/>
+              </a:rPr>
+              <a:t>Voljen kod publike zbog </a:t>
+            </a:r>
+            <a:r>
+              <a:rPr sz="1800" b="1">
+                <a:solidFill>
+                  <a:srgbClr val="1A1A1A"/>
+                </a:solidFill>
+                <a:latin typeface="Calibri"/>
+              </a:rPr>
+              <a:t>topline, autentičnosti i snažne ekranske pojave</a:t>
+            </a:r>
+            <a:r>
+              <a:rPr sz="1800" b="0">
+                <a:solidFill>
+                  <a:srgbClr val="1A1A1A"/>
+                </a:solidFill>
+                <a:latin typeface="Calibri"/>
+              </a:rPr>
+              <a:t>.</a:t>
             </a:r>
           </a:p>
           <a:p>
@@ -5482,7 +5788,7 @@
               <a:t>•  </a:t>
             </a:r>
             <a:r>
-              <a:rPr sz="1800">
+              <a:rPr sz="1800" b="0">
                 <a:solidFill>
                   <a:srgbClr val="1A1A1A"/>
                 </a:solidFill>
@@ -5612,7 +5918,7 @@
               <a:t>•  </a:t>
             </a:r>
             <a:r>
-              <a:rPr sz="1300">
+              <a:rPr sz="1300" b="0">
                 <a:solidFill>
                   <a:srgbClr val="FFFFFF"/>
                 </a:solidFill>
@@ -5640,7 +5946,7 @@
               <a:t>•  </a:t>
             </a:r>
             <a:r>
-              <a:rPr sz="1300">
+              <a:rPr sz="1300" b="0">
                 <a:solidFill>
                   <a:srgbClr val="FFFFFF"/>
                 </a:solidFill>
@@ -5668,7 +5974,7 @@
               <a:t>•  </a:t>
             </a:r>
             <a:r>
-              <a:rPr sz="1300">
+              <a:rPr sz="1300" b="0">
                 <a:solidFill>
                   <a:srgbClr val="FFFFFF"/>
                 </a:solidFill>
@@ -5696,7 +6002,7 @@
               <a:t>•  </a:t>
             </a:r>
             <a:r>
-              <a:rPr sz="1300">
+              <a:rPr sz="1300" b="0">
                 <a:solidFill>
                   <a:srgbClr val="FFFFFF"/>
                 </a:solidFill>
@@ -5961,13 +6267,67 @@
               <a:t>•  </a:t>
             </a:r>
             <a:r>
-              <a:rPr sz="1800">
-                <a:solidFill>
-                  <a:srgbClr val="1A1A1A"/>
-                </a:solidFill>
-                <a:latin typeface="Calibri"/>
-              </a:rPr>
-              <a:t>Rođen je 5. juna 1933. u selu Koraćica, u podnožju planine Kosmaj, blizu Mladenovca.</a:t>
+              <a:rPr sz="1800" b="0">
+                <a:solidFill>
+                  <a:srgbClr val="1A1A1A"/>
+                </a:solidFill>
+                <a:latin typeface="Calibri"/>
+              </a:rPr>
+              <a:t>Rođen je </a:t>
+            </a:r>
+            <a:r>
+              <a:rPr sz="1800" b="1">
+                <a:solidFill>
+                  <a:srgbClr val="1A1A1A"/>
+                </a:solidFill>
+                <a:latin typeface="Calibri"/>
+              </a:rPr>
+              <a:t>5. juna 1933.</a:t>
+            </a:r>
+            <a:r>
+              <a:rPr sz="1800" b="0">
+                <a:solidFill>
+                  <a:srgbClr val="1A1A1A"/>
+                </a:solidFill>
+                <a:latin typeface="Calibri"/>
+              </a:rPr>
+              <a:t> u selu </a:t>
+            </a:r>
+            <a:r>
+              <a:rPr sz="1800" b="1">
+                <a:solidFill>
+                  <a:srgbClr val="1A1A1A"/>
+                </a:solidFill>
+                <a:latin typeface="Calibri"/>
+              </a:rPr>
+              <a:t>Koraćica</a:t>
+            </a:r>
+            <a:r>
+              <a:rPr sz="1800" b="0">
+                <a:solidFill>
+                  <a:srgbClr val="1A1A1A"/>
+                </a:solidFill>
+                <a:latin typeface="Calibri"/>
+              </a:rPr>
+              <a:t>, u podnožju planine </a:t>
+            </a:r>
+            <a:r>
+              <a:rPr sz="1800" b="1">
+                <a:solidFill>
+                  <a:srgbClr val="1A1A1A"/>
+                </a:solidFill>
+                <a:latin typeface="Calibri"/>
+              </a:rPr>
+              <a:t>Kosmaj</a:t>
+            </a:r>
+            <a:r>
+              <a:rPr sz="1800" b="0">
+                <a:solidFill>
+                  <a:srgbClr val="1A1A1A"/>
+                </a:solidFill>
+                <a:latin typeface="Calibri"/>
+              </a:rPr>
+              <a:t>, blizu Mladenovca.</a:t>
             </a:r>
           </a:p>
           <a:p>
@@ -5989,13 +6349,31 @@
               <a:t>•  </a:t>
             </a:r>
             <a:r>
-              <a:rPr sz="1800">
-                <a:solidFill>
-                  <a:srgbClr val="1A1A1A"/>
-                </a:solidFill>
-                <a:latin typeface="Calibri"/>
-              </a:rPr>
-              <a:t>Detinjstvo je proveo u skromnim, seoskim uslovima, što je kasnije uticalo na njegove „narodne“ uloge.</a:t>
+              <a:rPr sz="1800" b="0">
+                <a:solidFill>
+                  <a:srgbClr val="1A1A1A"/>
+                </a:solidFill>
+                <a:latin typeface="Calibri"/>
+              </a:rPr>
+              <a:t>Detinjstvo je proveo u skromnim, </a:t>
+            </a:r>
+            <a:r>
+              <a:rPr sz="1800" b="1">
+                <a:solidFill>
+                  <a:srgbClr val="1A1A1A"/>
+                </a:solidFill>
+                <a:latin typeface="Calibri"/>
+              </a:rPr>
+              <a:t>seoskim uslovima</a:t>
+            </a:r>
+            <a:r>
+              <a:rPr sz="1800" b="0">
+                <a:solidFill>
+                  <a:srgbClr val="1A1A1A"/>
+                </a:solidFill>
+                <a:latin typeface="Calibri"/>
+              </a:rPr>
+              <a:t>, što je kasnije uticalo na njegove „narodne“ uloge.</a:t>
             </a:r>
           </a:p>
           <a:p>
@@ -6017,7 +6395,7 @@
               <a:t>•  </a:t>
             </a:r>
             <a:r>
-              <a:rPr sz="1800">
+              <a:rPr sz="1800" b="0">
                 <a:solidFill>
                   <a:srgbClr val="1A1A1A"/>
                 </a:solidFill>
@@ -6045,13 +6423,31 @@
               <a:t>•  </a:t>
             </a:r>
             <a:r>
-              <a:rPr sz="1800">
-                <a:solidFill>
-                  <a:srgbClr val="1A1A1A"/>
-                </a:solidFill>
-                <a:latin typeface="Calibri"/>
-              </a:rPr>
-              <a:t>Diplomirao je na Akademiji za pozorišnu umetnost u Beogradu.</a:t>
+              <a:rPr sz="1800" b="0">
+                <a:solidFill>
+                  <a:srgbClr val="1A1A1A"/>
+                </a:solidFill>
+                <a:latin typeface="Calibri"/>
+              </a:rPr>
+              <a:t>Diplomirao je na </a:t>
+            </a:r>
+            <a:r>
+              <a:rPr sz="1800" b="1">
+                <a:solidFill>
+                  <a:srgbClr val="1A1A1A"/>
+                </a:solidFill>
+                <a:latin typeface="Calibri"/>
+              </a:rPr>
+              <a:t>Akademiji za pozorišnu umetnost u Beogradu</a:t>
+            </a:r>
+            <a:r>
+              <a:rPr sz="1800" b="0">
+                <a:solidFill>
+                  <a:srgbClr val="1A1A1A"/>
+                </a:solidFill>
+                <a:latin typeface="Calibri"/>
+              </a:rPr>
+              <a:t>.</a:t>
             </a:r>
           </a:p>
           <a:p>
@@ -6073,13 +6469,49 @@
               <a:t>•  </a:t>
             </a:r>
             <a:r>
-              <a:rPr sz="1800">
-                <a:solidFill>
-                  <a:srgbClr val="1A1A1A"/>
-                </a:solidFill>
-                <a:latin typeface="Calibri"/>
-              </a:rPr>
-              <a:t>Karijeru je započeo u pozorištu, a ubrzo prešao na film, gde je stekao najveću slavu.</a:t>
+              <a:rPr sz="1800" b="0">
+                <a:solidFill>
+                  <a:srgbClr val="1A1A1A"/>
+                </a:solidFill>
+                <a:latin typeface="Calibri"/>
+              </a:rPr>
+              <a:t>Karijeru je započeo u </a:t>
+            </a:r>
+            <a:r>
+              <a:rPr sz="1800" b="1">
+                <a:solidFill>
+                  <a:srgbClr val="1A1A1A"/>
+                </a:solidFill>
+                <a:latin typeface="Calibri"/>
+              </a:rPr>
+              <a:t>pozorištu</a:t>
+            </a:r>
+            <a:r>
+              <a:rPr sz="1800" b="0">
+                <a:solidFill>
+                  <a:srgbClr val="1A1A1A"/>
+                </a:solidFill>
+                <a:latin typeface="Calibri"/>
+              </a:rPr>
+              <a:t>, a ubrzo prešao na </a:t>
+            </a:r>
+            <a:r>
+              <a:rPr sz="1800" b="1">
+                <a:solidFill>
+                  <a:srgbClr val="1A1A1A"/>
+                </a:solidFill>
+                <a:latin typeface="Calibri"/>
+              </a:rPr>
+              <a:t>film</a:t>
+            </a:r>
+            <a:r>
+              <a:rPr sz="1800" b="0">
+                <a:solidFill>
+                  <a:srgbClr val="1A1A1A"/>
+                </a:solidFill>
+                <a:latin typeface="Calibri"/>
+              </a:rPr>
+              <a:t>, gde je stekao najveću slavu.</a:t>
             </a:r>
           </a:p>
         </p:txBody>
@@ -6373,13 +6805,31 @@
               <a:t>•  </a:t>
             </a:r>
             <a:r>
-              <a:rPr sz="1700">
-                <a:solidFill>
-                  <a:srgbClr val="1A1A1A"/>
-                </a:solidFill>
-                <a:latin typeface="Calibri"/>
-              </a:rPr>
-              <a:t>Najveću popularnost stekao je u partizanskim ratnim filmovima, tumačeći hrabre borce i komandante:</a:t>
+              <a:rPr sz="1700" b="0">
+                <a:solidFill>
+                  <a:srgbClr val="1A1A1A"/>
+                </a:solidFill>
+                <a:latin typeface="Calibri"/>
+              </a:rPr>
+              <a:t>Najveću popularnost stekao je u </a:t>
+            </a:r>
+            <a:r>
+              <a:rPr sz="1700" b="1">
+                <a:solidFill>
+                  <a:srgbClr val="1A1A1A"/>
+                </a:solidFill>
+                <a:latin typeface="Calibri"/>
+              </a:rPr>
+              <a:t>partizanskim ratnim filmovima</a:t>
+            </a:r>
+            <a:r>
+              <a:rPr sz="1700" b="0">
+                <a:solidFill>
+                  <a:srgbClr val="1A1A1A"/>
+                </a:solidFill>
+                <a:latin typeface="Calibri"/>
+              </a:rPr>
+              <a:t>, tumačeći hrabre borce i komandante:</a:t>
             </a:r>
           </a:p>
           <a:p>
@@ -6401,13 +6851,22 @@
               <a:t>-  </a:t>
             </a:r>
             <a:r>
-              <a:rPr sz="1500">
-                <a:solidFill>
-                  <a:srgbClr val="1A1A1A"/>
-                </a:solidFill>
-                <a:latin typeface="Calibri"/>
-              </a:rPr>
-              <a:t>„Bitka na Neretvi“ (1969)</a:t>
+              <a:rPr sz="1500" b="1">
+                <a:solidFill>
+                  <a:srgbClr val="1A1A1A"/>
+                </a:solidFill>
+                <a:latin typeface="Calibri"/>
+              </a:rPr>
+              <a:t>„Bitka na Neretvi“</a:t>
+            </a:r>
+            <a:r>
+              <a:rPr sz="1500" b="0">
+                <a:solidFill>
+                  <a:srgbClr val="1A1A1A"/>
+                </a:solidFill>
+                <a:latin typeface="Calibri"/>
+              </a:rPr>
+              <a:t> (1969)</a:t>
             </a:r>
           </a:p>
           <a:p>
@@ -6429,13 +6888,22 @@
               <a:t>-  </a:t>
             </a:r>
             <a:r>
-              <a:rPr sz="1500">
-                <a:solidFill>
-                  <a:srgbClr val="1A1A1A"/>
-                </a:solidFill>
-                <a:latin typeface="Calibri"/>
-              </a:rPr>
-              <a:t>„Most“ (1969)</a:t>
+              <a:rPr sz="1500" b="1">
+                <a:solidFill>
+                  <a:srgbClr val="1A1A1A"/>
+                </a:solidFill>
+                <a:latin typeface="Calibri"/>
+              </a:rPr>
+              <a:t>„Most“</a:t>
+            </a:r>
+            <a:r>
+              <a:rPr sz="1500" b="0">
+                <a:solidFill>
+                  <a:srgbClr val="1A1A1A"/>
+                </a:solidFill>
+                <a:latin typeface="Calibri"/>
+              </a:rPr>
+              <a:t> (1969)</a:t>
             </a:r>
           </a:p>
           <a:p>
@@ -6457,13 +6925,22 @@
               <a:t>-  </a:t>
             </a:r>
             <a:r>
-              <a:rPr sz="1500">
-                <a:solidFill>
-                  <a:srgbClr val="1A1A1A"/>
-                </a:solidFill>
-                <a:latin typeface="Calibri"/>
-              </a:rPr>
-              <a:t>„Valter brani Sarajevo“ (1972)</a:t>
+              <a:rPr sz="1500" b="1">
+                <a:solidFill>
+                  <a:srgbClr val="1A1A1A"/>
+                </a:solidFill>
+                <a:latin typeface="Calibri"/>
+              </a:rPr>
+              <a:t>„Valter brani Sarajevo“</a:t>
+            </a:r>
+            <a:r>
+              <a:rPr sz="1500" b="0">
+                <a:solidFill>
+                  <a:srgbClr val="1A1A1A"/>
+                </a:solidFill>
+                <a:latin typeface="Calibri"/>
+              </a:rPr>
+              <a:t> (1972)</a:t>
             </a:r>
           </a:p>
           <a:p>
@@ -6485,13 +6962,31 @@
               <a:t>-  </a:t>
             </a:r>
             <a:r>
-              <a:rPr sz="1500">
-                <a:solidFill>
-                  <a:srgbClr val="1A1A1A"/>
-                </a:solidFill>
-                <a:latin typeface="Calibri"/>
-              </a:rPr>
-              <a:t>„Sutjeska“ (1973) - uz Ričarda Bartona</a:t>
+              <a:rPr sz="1500" b="1">
+                <a:solidFill>
+                  <a:srgbClr val="1A1A1A"/>
+                </a:solidFill>
+                <a:latin typeface="Calibri"/>
+              </a:rPr>
+              <a:t>„Sutjeska“</a:t>
+            </a:r>
+            <a:r>
+              <a:rPr sz="1500" b="0">
+                <a:solidFill>
+                  <a:srgbClr val="1A1A1A"/>
+                </a:solidFill>
+                <a:latin typeface="Calibri"/>
+              </a:rPr>
+              <a:t> (1973) - uz </a:t>
+            </a:r>
+            <a:r>
+              <a:rPr sz="1500" b="1">
+                <a:solidFill>
+                  <a:srgbClr val="1A1A1A"/>
+                </a:solidFill>
+                <a:latin typeface="Calibri"/>
+              </a:rPr>
+              <a:t>Ričarda Bartona</a:t>
             </a:r>
           </a:p>
           <a:p>
@@ -6513,13 +7008,31 @@
               <a:t>•  </a:t>
             </a:r>
             <a:r>
-              <a:rPr sz="1700">
-                <a:solidFill>
-                  <a:srgbClr val="1A1A1A"/>
-                </a:solidFill>
-                <a:latin typeface="Calibri"/>
-              </a:rPr>
-              <a:t>Igrao je i u komedijama, dramama i istorijskim filmovima - veliki glumački raspon.</a:t>
+              <a:rPr sz="1700" b="0">
+                <a:solidFill>
+                  <a:srgbClr val="1A1A1A"/>
+                </a:solidFill>
+                <a:latin typeface="Calibri"/>
+              </a:rPr>
+              <a:t>Igrao je i u komedijama, dramama i istorijskim filmovima - </a:t>
+            </a:r>
+            <a:r>
+              <a:rPr sz="1700" b="1">
+                <a:solidFill>
+                  <a:srgbClr val="1A1A1A"/>
+                </a:solidFill>
+                <a:latin typeface="Calibri"/>
+              </a:rPr>
+              <a:t>veliki glumački raspon</a:t>
+            </a:r>
+            <a:r>
+              <a:rPr sz="1700" b="0">
+                <a:solidFill>
+                  <a:srgbClr val="1A1A1A"/>
+                </a:solidFill>
+                <a:latin typeface="Calibri"/>
+              </a:rPr>
+              <a:t>.</a:t>
             </a:r>
           </a:p>
           <a:p>
@@ -6541,13 +7054,31 @@
               <a:t>•  </a:t>
             </a:r>
             <a:r>
-              <a:rPr sz="1700">
-                <a:solidFill>
-                  <a:srgbClr val="1A1A1A"/>
-                </a:solidFill>
-                <a:latin typeface="Calibri"/>
-              </a:rPr>
-              <a:t>Njegova pojava postala je zaštitni znak čitave epohe domaćeg filma.</a:t>
+              <a:rPr sz="1700" b="0">
+                <a:solidFill>
+                  <a:srgbClr val="1A1A1A"/>
+                </a:solidFill>
+                <a:latin typeface="Calibri"/>
+              </a:rPr>
+              <a:t>Njegova pojava postala je </a:t>
+            </a:r>
+            <a:r>
+              <a:rPr sz="1700" b="1">
+                <a:solidFill>
+                  <a:srgbClr val="1A1A1A"/>
+                </a:solidFill>
+                <a:latin typeface="Calibri"/>
+              </a:rPr>
+              <a:t>zaštitni znak čitave epohe</a:t>
+            </a:r>
+            <a:r>
+              <a:rPr sz="1700" b="0">
+                <a:solidFill>
+                  <a:srgbClr val="1A1A1A"/>
+                </a:solidFill>
+                <a:latin typeface="Calibri"/>
+              </a:rPr>
+              <a:t> domaćeg filma.</a:t>
             </a:r>
           </a:p>
         </p:txBody>
@@ -6806,7 +7337,7 @@
               <a:t>•  </a:t>
             </a:r>
             <a:r>
-              <a:rPr sz="1800">
+              <a:rPr sz="1800" b="0">
                 <a:solidFill>
                   <a:srgbClr val="1A1A1A"/>
                 </a:solidFill>
@@ -6834,13 +7365,31 @@
               <a:t>•  </a:t>
             </a:r>
             <a:r>
-              <a:rPr sz="1800">
-                <a:solidFill>
-                  <a:srgbClr val="1A1A1A"/>
-                </a:solidFill>
-                <a:latin typeface="Calibri"/>
-              </a:rPr>
-              <a:t>Glumio je u kultnim TV serijama koje su pratile generacije gledalaca:</a:t>
+              <a:rPr sz="1800" b="0">
+                <a:solidFill>
+                  <a:srgbClr val="1A1A1A"/>
+                </a:solidFill>
+                <a:latin typeface="Calibri"/>
+              </a:rPr>
+              <a:t>Glumio je u </a:t>
+            </a:r>
+            <a:r>
+              <a:rPr sz="1800" b="1">
+                <a:solidFill>
+                  <a:srgbClr val="1A1A1A"/>
+                </a:solidFill>
+                <a:latin typeface="Calibri"/>
+              </a:rPr>
+              <a:t>kultnim TV serijama</a:t>
+            </a:r>
+            <a:r>
+              <a:rPr sz="1800" b="0">
+                <a:solidFill>
+                  <a:srgbClr val="1A1A1A"/>
+                </a:solidFill>
+                <a:latin typeface="Calibri"/>
+              </a:rPr>
+              <a:t> koje su pratile generacije gledalaca:</a:t>
             </a:r>
           </a:p>
           <a:p>
@@ -6862,13 +7411,40 @@
               <a:t>-  </a:t>
             </a:r>
             <a:r>
-              <a:rPr sz="1600">
-                <a:solidFill>
-                  <a:srgbClr val="1A1A1A"/>
-                </a:solidFill>
-                <a:latin typeface="Calibri"/>
-              </a:rPr>
-              <a:t>„Otpisani“ i „Povratak otpisanih“ - priče o beogradskim ilegalcima u Drugom svetskom ratu.</a:t>
+              <a:rPr sz="1600" b="1">
+                <a:solidFill>
+                  <a:srgbClr val="1A1A1A"/>
+                </a:solidFill>
+                <a:latin typeface="Calibri"/>
+              </a:rPr>
+              <a:t>„Otpisani“</a:t>
+            </a:r>
+            <a:r>
+              <a:rPr sz="1600" b="0">
+                <a:solidFill>
+                  <a:srgbClr val="1A1A1A"/>
+                </a:solidFill>
+                <a:latin typeface="Calibri"/>
+              </a:rPr>
+              <a:t> i </a:t>
+            </a:r>
+            <a:r>
+              <a:rPr sz="1600" b="1">
+                <a:solidFill>
+                  <a:srgbClr val="1A1A1A"/>
+                </a:solidFill>
+                <a:latin typeface="Calibri"/>
+              </a:rPr>
+              <a:t>„Povratak otpisanih“</a:t>
+            </a:r>
+            <a:r>
+              <a:rPr sz="1600" b="0">
+                <a:solidFill>
+                  <a:srgbClr val="1A1A1A"/>
+                </a:solidFill>
+                <a:latin typeface="Calibri"/>
+              </a:rPr>
+              <a:t> - priče o beogradskim ilegalcima u Drugom svetskom ratu.</a:t>
             </a:r>
           </a:p>
           <a:p>
@@ -6890,7 +7466,7 @@
               <a:t>•  </a:t>
             </a:r>
             <a:r>
-              <a:rPr sz="1800">
+              <a:rPr sz="1800" b="0">
                 <a:solidFill>
                   <a:srgbClr val="1A1A1A"/>
                 </a:solidFill>
@@ -6918,13 +7494,31 @@
               <a:t>•  </a:t>
             </a:r>
             <a:r>
-              <a:rPr sz="1800">
-                <a:solidFill>
-                  <a:srgbClr val="1A1A1A"/>
-                </a:solidFill>
-                <a:latin typeface="Calibri"/>
-              </a:rPr>
-              <a:t>Zahvaljujući televiziji, postao je omiljen u svakom domu bivše Jugoslavije.</a:t>
+              <a:rPr sz="1800" b="0">
+                <a:solidFill>
+                  <a:srgbClr val="1A1A1A"/>
+                </a:solidFill>
+                <a:latin typeface="Calibri"/>
+              </a:rPr>
+              <a:t>Zahvaljujući televiziji, postao je </a:t>
+            </a:r>
+            <a:r>
+              <a:rPr sz="1800" b="1">
+                <a:solidFill>
+                  <a:srgbClr val="1A1A1A"/>
+                </a:solidFill>
+                <a:latin typeface="Calibri"/>
+              </a:rPr>
+              <a:t>omiljen u svakom domu</a:t>
+            </a:r>
+            <a:r>
+              <a:rPr sz="1800" b="0">
+                <a:solidFill>
+                  <a:srgbClr val="1A1A1A"/>
+                </a:solidFill>
+                <a:latin typeface="Calibri"/>
+              </a:rPr>
+              <a:t> bivše Jugoslavije.</a:t>
             </a:r>
           </a:p>
         </p:txBody>
@@ -7183,13 +7777,31 @@
               <a:t>•  </a:t>
             </a:r>
             <a:r>
-              <a:rPr sz="1800">
-                <a:solidFill>
-                  <a:srgbClr val="1A1A1A"/>
-                </a:solidFill>
-                <a:latin typeface="Calibri"/>
-              </a:rPr>
-              <a:t>U drugom delu života aktivno se bavio politikom.</a:t>
+              <a:rPr sz="1800" b="0">
+                <a:solidFill>
+                  <a:srgbClr val="1A1A1A"/>
+                </a:solidFill>
+                <a:latin typeface="Calibri"/>
+              </a:rPr>
+              <a:t>U drugom delu života aktivno se bavio </a:t>
+            </a:r>
+            <a:r>
+              <a:rPr sz="1800" b="1">
+                <a:solidFill>
+                  <a:srgbClr val="1A1A1A"/>
+                </a:solidFill>
+                <a:latin typeface="Calibri"/>
+              </a:rPr>
+              <a:t>politikom</a:t>
+            </a:r>
+            <a:r>
+              <a:rPr sz="1800" b="0">
+                <a:solidFill>
+                  <a:srgbClr val="1A1A1A"/>
+                </a:solidFill>
+                <a:latin typeface="Calibri"/>
+              </a:rPr>
+              <a:t>.</a:t>
             </a:r>
           </a:p>
           <a:p>
@@ -7211,13 +7823,31 @@
               <a:t>•  </a:t>
             </a:r>
             <a:r>
-              <a:rPr sz="1800">
-                <a:solidFill>
-                  <a:srgbClr val="1A1A1A"/>
-                </a:solidFill>
-                <a:latin typeface="Calibri"/>
-              </a:rPr>
-              <a:t>Bio je član Socijalističke partije Srbije (SPS).</a:t>
+              <a:rPr sz="1800" b="0">
+                <a:solidFill>
+                  <a:srgbClr val="1A1A1A"/>
+                </a:solidFill>
+                <a:latin typeface="Calibri"/>
+              </a:rPr>
+              <a:t>Bio je član </a:t>
+            </a:r>
+            <a:r>
+              <a:rPr sz="1800" b="1">
+                <a:solidFill>
+                  <a:srgbClr val="1A1A1A"/>
+                </a:solidFill>
+                <a:latin typeface="Calibri"/>
+              </a:rPr>
+              <a:t>Socijalističke partije Srbije (SPS)</a:t>
+            </a:r>
+            <a:r>
+              <a:rPr sz="1800" b="0">
+                <a:solidFill>
+                  <a:srgbClr val="1A1A1A"/>
+                </a:solidFill>
+                <a:latin typeface="Calibri"/>
+              </a:rPr>
+              <a:t>.</a:t>
             </a:r>
           </a:p>
           <a:p>
@@ -7239,13 +7869,31 @@
               <a:t>•  </a:t>
             </a:r>
             <a:r>
-              <a:rPr sz="1800">
-                <a:solidFill>
-                  <a:srgbClr val="1A1A1A"/>
-                </a:solidFill>
-                <a:latin typeface="Calibri"/>
-              </a:rPr>
-              <a:t>Više puta je biran za narodnog poslanika u Skupštini.</a:t>
+              <a:rPr sz="1800" b="0">
+                <a:solidFill>
+                  <a:srgbClr val="1A1A1A"/>
+                </a:solidFill>
+                <a:latin typeface="Calibri"/>
+              </a:rPr>
+              <a:t>Više puta je biran za </a:t>
+            </a:r>
+            <a:r>
+              <a:rPr sz="1800" b="1">
+                <a:solidFill>
+                  <a:srgbClr val="1A1A1A"/>
+                </a:solidFill>
+                <a:latin typeface="Calibri"/>
+              </a:rPr>
+              <a:t>narodnog poslanika</a:t>
+            </a:r>
+            <a:r>
+              <a:rPr sz="1800" b="0">
+                <a:solidFill>
+                  <a:srgbClr val="1A1A1A"/>
+                </a:solidFill>
+                <a:latin typeface="Calibri"/>
+              </a:rPr>
+              <a:t> u Skupštini.</a:t>
             </a:r>
           </a:p>
           <a:p>
@@ -7267,7 +7915,7 @@
               <a:t>•  </a:t>
             </a:r>
             <a:r>
-              <a:rPr sz="1800">
+              <a:rPr sz="1800" b="0">
                 <a:solidFill>
                   <a:srgbClr val="1A1A1A"/>
                 </a:solidFill>
@@ -7295,7 +7943,7 @@
               <a:t>•  </a:t>
             </a:r>
             <a:r>
-              <a:rPr sz="1800">
+              <a:rPr sz="1800" b="0">
                 <a:solidFill>
                   <a:srgbClr val="1A1A1A"/>
                 </a:solidFill>
@@ -7595,13 +8243,31 @@
               <a:t>•  </a:t>
             </a:r>
             <a:r>
-              <a:rPr sz="1800">
-                <a:solidFill>
-                  <a:srgbClr val="1A1A1A"/>
-                </a:solidFill>
-                <a:latin typeface="Calibri"/>
-              </a:rPr>
-              <a:t>Reditelj: Srđan Dragojević.</a:t>
+              <a:rPr sz="1800" b="0">
+                <a:solidFill>
+                  <a:srgbClr val="1A1A1A"/>
+                </a:solidFill>
+                <a:latin typeface="Calibri"/>
+              </a:rPr>
+              <a:t>Reditelj: </a:t>
+            </a:r>
+            <a:r>
+              <a:rPr sz="1800" b="1">
+                <a:solidFill>
+                  <a:srgbClr val="1A1A1A"/>
+                </a:solidFill>
+                <a:latin typeface="Calibri"/>
+              </a:rPr>
+              <a:t>Srđan Dragojević</a:t>
+            </a:r>
+            <a:r>
+              <a:rPr sz="1800" b="0">
+                <a:solidFill>
+                  <a:srgbClr val="1A1A1A"/>
+                </a:solidFill>
+                <a:latin typeface="Calibri"/>
+              </a:rPr>
+              <a:t>.</a:t>
             </a:r>
           </a:p>
           <a:p>
@@ -7623,13 +8289,31 @@
               <a:t>•  </a:t>
             </a:r>
             <a:r>
-              <a:rPr sz="1800">
-                <a:solidFill>
-                  <a:srgbClr val="1A1A1A"/>
-                </a:solidFill>
-                <a:latin typeface="Calibri"/>
-              </a:rPr>
-              <a:t>Jedan od najznačajnijih i najpotresnijih srpskih filmova o ratu u Bosni (1992-1995).</a:t>
+              <a:rPr sz="1800" b="0">
+                <a:solidFill>
+                  <a:srgbClr val="1A1A1A"/>
+                </a:solidFill>
+                <a:latin typeface="Calibri"/>
+              </a:rPr>
+              <a:t>Jedan od </a:t>
+            </a:r>
+            <a:r>
+              <a:rPr sz="1800" b="1">
+                <a:solidFill>
+                  <a:srgbClr val="1A1A1A"/>
+                </a:solidFill>
+                <a:latin typeface="Calibri"/>
+              </a:rPr>
+              <a:t>najznačajnijih i najpotresnijih</a:t>
+            </a:r>
+            <a:r>
+              <a:rPr sz="1800" b="0">
+                <a:solidFill>
+                  <a:srgbClr val="1A1A1A"/>
+                </a:solidFill>
+                <a:latin typeface="Calibri"/>
+              </a:rPr>
+              <a:t> srpskih filmova o ratu u Bosni (1992-1995).</a:t>
             </a:r>
           </a:p>
           <a:p>
@@ -7651,13 +8335,31 @@
               <a:t>•  </a:t>
             </a:r>
             <a:r>
-              <a:rPr sz="1800">
-                <a:solidFill>
-                  <a:srgbClr val="1A1A1A"/>
-                </a:solidFill>
-                <a:latin typeface="Calibri"/>
-              </a:rPr>
-              <a:t>Radnja prati grupu srpskih boraca zarobljenih u tunelu, okruženih neprijateljskim snagama.</a:t>
+              <a:rPr sz="1800" b="0">
+                <a:solidFill>
+                  <a:srgbClr val="1A1A1A"/>
+                </a:solidFill>
+                <a:latin typeface="Calibri"/>
+              </a:rPr>
+              <a:t>Radnja prati grupu srpskih boraca </a:t>
+            </a:r>
+            <a:r>
+              <a:rPr sz="1800" b="1">
+                <a:solidFill>
+                  <a:srgbClr val="1A1A1A"/>
+                </a:solidFill>
+                <a:latin typeface="Calibri"/>
+              </a:rPr>
+              <a:t>zarobljenih u tunelu</a:t>
+            </a:r>
+            <a:r>
+              <a:rPr sz="1800" b="0">
+                <a:solidFill>
+                  <a:srgbClr val="1A1A1A"/>
+                </a:solidFill>
+                <a:latin typeface="Calibri"/>
+              </a:rPr>
+              <a:t>, okruženih neprijateljskim snagama.</a:t>
             </a:r>
           </a:p>
           <a:p>
@@ -7679,13 +8381,31 @@
               <a:t>•  </a:t>
             </a:r>
             <a:r>
-              <a:rPr sz="1800">
-                <a:solidFill>
-                  <a:srgbClr val="1A1A1A"/>
-                </a:solidFill>
-                <a:latin typeface="Calibri"/>
-              </a:rPr>
-              <a:t>Kroz potresne scene prikazuje besmisao rata i raspad nekadašnjeg „bratstva i jedinstva“.</a:t>
+              <a:rPr sz="1800" b="0">
+                <a:solidFill>
+                  <a:srgbClr val="1A1A1A"/>
+                </a:solidFill>
+                <a:latin typeface="Calibri"/>
+              </a:rPr>
+              <a:t>Kroz potresne scene prikazuje </a:t>
+            </a:r>
+            <a:r>
+              <a:rPr sz="1800" b="1">
+                <a:solidFill>
+                  <a:srgbClr val="1A1A1A"/>
+                </a:solidFill>
+                <a:latin typeface="Calibri"/>
+              </a:rPr>
+              <a:t>besmisao rata</a:t>
+            </a:r>
+            <a:r>
+              <a:rPr sz="1800" b="0">
+                <a:solidFill>
+                  <a:srgbClr val="1A1A1A"/>
+                </a:solidFill>
+                <a:latin typeface="Calibri"/>
+              </a:rPr>
+              <a:t> i raspad nekadašnjeg „bratstva i jedinstva“.</a:t>
             </a:r>
           </a:p>
           <a:p>
@@ -7707,13 +8427,22 @@
               <a:t>•  </a:t>
             </a:r>
             <a:r>
-              <a:rPr sz="1800">
-                <a:solidFill>
-                  <a:srgbClr val="1A1A1A"/>
-                </a:solidFill>
-                <a:latin typeface="Calibri"/>
-              </a:rPr>
-              <a:t>Antiratni film - ne slavi rat, već pokazuje njegovu tragediju i ljudsku patnju.</a:t>
+              <a:rPr sz="1800" b="1">
+                <a:solidFill>
+                  <a:srgbClr val="1A1A1A"/>
+                </a:solidFill>
+                <a:latin typeface="Calibri"/>
+              </a:rPr>
+              <a:t>Antiratni film</a:t>
+            </a:r>
+            <a:r>
+              <a:rPr sz="1800" b="0">
+                <a:solidFill>
+                  <a:srgbClr val="1A1A1A"/>
+                </a:solidFill>
+                <a:latin typeface="Calibri"/>
+              </a:rPr>
+              <a:t> - ne slavi rat, već pokazuje njegovu tragediju i ljudsku patnju.</a:t>
             </a:r>
           </a:p>
         </p:txBody>
@@ -7837,13 +8566,31 @@
               <a:t>•  </a:t>
             </a:r>
             <a:r>
-              <a:rPr sz="1400">
+              <a:rPr sz="1400" b="0">
                 <a:solidFill>
                   <a:srgbClr val="FFFFFF"/>
                 </a:solidFill>
                 <a:latin typeface="Calibri"/>
               </a:rPr>
-              <a:t>Tunel je simbol - bezizlazna situacija i zarobljenost u mržnji rata.</a:t>
+              <a:t>Tunel je </a:t>
+            </a:r>
+            <a:r>
+              <a:rPr sz="1400" b="1">
+                <a:solidFill>
+                  <a:srgbClr val="FFFFFF"/>
+                </a:solidFill>
+                <a:latin typeface="Calibri"/>
+              </a:rPr>
+              <a:t>simbol</a:t>
+            </a:r>
+            <a:r>
+              <a:rPr sz="1400" b="0">
+                <a:solidFill>
+                  <a:srgbClr val="FFFFFF"/>
+                </a:solidFill>
+                <a:latin typeface="Calibri"/>
+              </a:rPr>
+              <a:t> - bezizlazna situacija i zarobljenost u mržnji rata.</a:t>
             </a:r>
           </a:p>
           <a:p>
@@ -7865,13 +8612,31 @@
               <a:t>•  </a:t>
             </a:r>
             <a:r>
-              <a:rPr sz="1400">
+              <a:rPr sz="1400" b="0">
                 <a:solidFill>
                   <a:srgbClr val="FFFFFF"/>
                 </a:solidFill>
                 <a:latin typeface="Calibri"/>
               </a:rPr>
-              <a:t>Film je dobio brojne nagrade i prikazivan je širom sveta.</a:t>
+              <a:t>Film je dobio </a:t>
+            </a:r>
+            <a:r>
+              <a:rPr sz="1400" b="1">
+                <a:solidFill>
+                  <a:srgbClr val="FFFFFF"/>
+                </a:solidFill>
+                <a:latin typeface="Calibri"/>
+              </a:rPr>
+              <a:t>brojne nagrade</a:t>
+            </a:r>
+            <a:r>
+              <a:rPr sz="1400" b="0">
+                <a:solidFill>
+                  <a:srgbClr val="FFFFFF"/>
+                </a:solidFill>
+                <a:latin typeface="Calibri"/>
+              </a:rPr>
+              <a:t> i prikazivan je širom sveta.</a:t>
             </a:r>
           </a:p>
           <a:p>
@@ -7893,13 +8658,31 @@
               <a:t>•  </a:t>
             </a:r>
             <a:r>
-              <a:rPr sz="1400">
+              <a:rPr sz="1400" b="0">
                 <a:solidFill>
                   <a:srgbClr val="FFFFFF"/>
                 </a:solidFill>
                 <a:latin typeface="Calibri"/>
               </a:rPr>
-              <a:t>Naziv potiče iz crnog humora kojim se borci brane od strave rata.</a:t>
+              <a:t>Naziv potiče iz </a:t>
+            </a:r>
+            <a:r>
+              <a:rPr sz="1400" b="1">
+                <a:solidFill>
+                  <a:srgbClr val="FFFFFF"/>
+                </a:solidFill>
+                <a:latin typeface="Calibri"/>
+              </a:rPr>
+              <a:t>crnog humora</a:t>
+            </a:r>
+            <a:r>
+              <a:rPr sz="1400" b="0">
+                <a:solidFill>
+                  <a:srgbClr val="FFFFFF"/>
+                </a:solidFill>
+                <a:latin typeface="Calibri"/>
+              </a:rPr>
+              <a:t> kojim se borci brane od strave rata.</a:t>
             </a:r>
           </a:p>
         </p:txBody>
@@ -8128,13 +8911,31 @@
               <a:t>•  </a:t>
             </a:r>
             <a:r>
-              <a:rPr sz="1700">
-                <a:solidFill>
-                  <a:srgbClr val="1A1A1A"/>
-                </a:solidFill>
-                <a:latin typeface="Calibri"/>
-              </a:rPr>
-              <a:t>Bata Živojinović tumači Gvozdena - starijeg, iskusnog borca među zarobljenim vojnicima.</a:t>
+              <a:rPr sz="1700" b="0">
+                <a:solidFill>
+                  <a:srgbClr val="1A1A1A"/>
+                </a:solidFill>
+                <a:latin typeface="Calibri"/>
+              </a:rPr>
+              <a:t>Bata Živojinović tumači </a:t>
+            </a:r>
+            <a:r>
+              <a:rPr sz="1700" b="1">
+                <a:solidFill>
+                  <a:srgbClr val="1A1A1A"/>
+                </a:solidFill>
+                <a:latin typeface="Calibri"/>
+              </a:rPr>
+              <a:t>Gvozdena</a:t>
+            </a:r>
+            <a:r>
+              <a:rPr sz="1700" b="0">
+                <a:solidFill>
+                  <a:srgbClr val="1A1A1A"/>
+                </a:solidFill>
+                <a:latin typeface="Calibri"/>
+              </a:rPr>
+              <a:t> - starijeg, iskusnog borca među zarobljenim vojnicima.</a:t>
             </a:r>
           </a:p>
           <a:p>
@@ -8156,13 +8957,31 @@
               <a:t>•  </a:t>
             </a:r>
             <a:r>
-              <a:rPr sz="1700">
-                <a:solidFill>
-                  <a:srgbClr val="1A1A1A"/>
-                </a:solidFill>
-                <a:latin typeface="Calibri"/>
-              </a:rPr>
-              <a:t>Gvozden je nekadašnji radnik koji je iskreno verovao u ideale „bratstva i jedinstva“ socijalističke Jugoslavije.</a:t>
+              <a:rPr sz="1700" b="0">
+                <a:solidFill>
+                  <a:srgbClr val="1A1A1A"/>
+                </a:solidFill>
+                <a:latin typeface="Calibri"/>
+              </a:rPr>
+              <a:t>Gvozden je nekadašnji radnik koji je iskreno verovao u ideale </a:t>
+            </a:r>
+            <a:r>
+              <a:rPr sz="1700" b="1">
+                <a:solidFill>
+                  <a:srgbClr val="1A1A1A"/>
+                </a:solidFill>
+                <a:latin typeface="Calibri"/>
+              </a:rPr>
+              <a:t>„bratstva i jedinstva“</a:t>
+            </a:r>
+            <a:r>
+              <a:rPr sz="1700" b="0">
+                <a:solidFill>
+                  <a:srgbClr val="1A1A1A"/>
+                </a:solidFill>
+                <a:latin typeface="Calibri"/>
+              </a:rPr>
+              <a:t> socijalističke Jugoslavije.</a:t>
             </a:r>
           </a:p>
           <a:p>
@@ -8184,13 +9003,31 @@
               <a:t>•  </a:t>
             </a:r>
             <a:r>
-              <a:rPr sz="1700">
-                <a:solidFill>
-                  <a:srgbClr val="1A1A1A"/>
-                </a:solidFill>
-                <a:latin typeface="Calibri"/>
-              </a:rPr>
-              <a:t>Predstavlja stariju generaciju - onu koja je gradila zajedničku zemlju i ne može da prihvati da se ona ruši u krvi.</a:t>
+              <a:rPr sz="1700" b="0">
+                <a:solidFill>
+                  <a:srgbClr val="1A1A1A"/>
+                </a:solidFill>
+                <a:latin typeface="Calibri"/>
+              </a:rPr>
+              <a:t>Predstavlja </a:t>
+            </a:r>
+            <a:r>
+              <a:rPr sz="1700" b="1">
+                <a:solidFill>
+                  <a:srgbClr val="1A1A1A"/>
+                </a:solidFill>
+                <a:latin typeface="Calibri"/>
+              </a:rPr>
+              <a:t>stariju generaciju</a:t>
+            </a:r>
+            <a:r>
+              <a:rPr sz="1700" b="0">
+                <a:solidFill>
+                  <a:srgbClr val="1A1A1A"/>
+                </a:solidFill>
+                <a:latin typeface="Calibri"/>
+              </a:rPr>
+              <a:t> - onu koja je gradila zajedničku zemlju i ne može da prihvati da se ona ruši u krvi.</a:t>
             </a:r>
           </a:p>
           <a:p>
@@ -8212,13 +9049,31 @@
               <a:t>•  </a:t>
             </a:r>
             <a:r>
-              <a:rPr sz="1700">
-                <a:solidFill>
-                  <a:srgbClr val="1A1A1A"/>
-                </a:solidFill>
-                <a:latin typeface="Calibri"/>
-              </a:rPr>
-              <a:t>Kako rat odmiče, sve više gubi nadu i razočaran je u sve oko sebe.</a:t>
+              <a:rPr sz="1700" b="0">
+                <a:solidFill>
+                  <a:srgbClr val="1A1A1A"/>
+                </a:solidFill>
+                <a:latin typeface="Calibri"/>
+              </a:rPr>
+              <a:t>Kako rat odmiče, sve više </a:t>
+            </a:r>
+            <a:r>
+              <a:rPr sz="1700" b="1">
+                <a:solidFill>
+                  <a:srgbClr val="1A1A1A"/>
+                </a:solidFill>
+                <a:latin typeface="Calibri"/>
+              </a:rPr>
+              <a:t>gubi nadu</a:t>
+            </a:r>
+            <a:r>
+              <a:rPr sz="1700" b="0">
+                <a:solidFill>
+                  <a:srgbClr val="1A1A1A"/>
+                </a:solidFill>
+                <a:latin typeface="Calibri"/>
+              </a:rPr>
+              <a:t> i razočaran je u sve oko sebe.</a:t>
             </a:r>
           </a:p>
           <a:p>
@@ -8240,13 +9095,22 @@
               <a:t>•  </a:t>
             </a:r>
             <a:r>
-              <a:rPr sz="1700">
-                <a:solidFill>
-                  <a:srgbClr val="1A1A1A"/>
-                </a:solidFill>
-                <a:latin typeface="Calibri"/>
-              </a:rPr>
-              <a:t>Tragičan lik - simbol sloma jednog sistema vrednosti i jedne epohe.</a:t>
+              <a:rPr sz="1700" b="1">
+                <a:solidFill>
+                  <a:srgbClr val="1A1A1A"/>
+                </a:solidFill>
+                <a:latin typeface="Calibri"/>
+              </a:rPr>
+              <a:t>Tragičan lik</a:t>
+            </a:r>
+            <a:r>
+              <a:rPr sz="1700" b="0">
+                <a:solidFill>
+                  <a:srgbClr val="1A1A1A"/>
+                </a:solidFill>
+                <a:latin typeface="Calibri"/>
+              </a:rPr>
+              <a:t> - simbol sloma jednog sistema vrednosti i jedne epohe.</a:t>
             </a:r>
           </a:p>
           <a:p>
@@ -8268,13 +9132,31 @@
               <a:t>•  </a:t>
             </a:r>
             <a:r>
-              <a:rPr sz="1700">
-                <a:solidFill>
-                  <a:srgbClr val="1A1A1A"/>
-                </a:solidFill>
-                <a:latin typeface="Calibri"/>
-              </a:rPr>
-              <a:t>U trenutku potpunog očaja donosi sudbonosnu, samoubilačku odluku - jedna od najupečatljivijih scena filma.</a:t>
+              <a:rPr sz="1700" b="0">
+                <a:solidFill>
+                  <a:srgbClr val="1A1A1A"/>
+                </a:solidFill>
+                <a:latin typeface="Calibri"/>
+              </a:rPr>
+              <a:t>U trenutku potpunog očaja donosi </a:t>
+            </a:r>
+            <a:r>
+              <a:rPr sz="1700" b="1">
+                <a:solidFill>
+                  <a:srgbClr val="1A1A1A"/>
+                </a:solidFill>
+                <a:latin typeface="Calibri"/>
+              </a:rPr>
+              <a:t>sudbonosnu, samoubilačku odluku</a:t>
+            </a:r>
+            <a:r>
+              <a:rPr sz="1700" b="0">
+                <a:solidFill>
+                  <a:srgbClr val="1A1A1A"/>
+                </a:solidFill>
+                <a:latin typeface="Calibri"/>
+              </a:rPr>
+              <a:t> - jedna od najupečatljivijih scena filma.</a:t>
             </a:r>
           </a:p>
         </p:txBody>

</xml_diff>